<commit_message>
Fix login logout data
</commit_message>
<xml_diff>
--- a/ppt/Reporting2.pptx
+++ b/ppt/Reporting2.pptx
@@ -21,7 +21,6 @@
     <p:sldId id="269" r:id="rId16"/>
     <p:sldId id="270" r:id="rId17"/>
     <p:sldId id="271" r:id="rId18"/>
-    <p:sldId id="272" r:id="rId19"/>
   </p:sldIdLst>
   <p:sldSz cx="10080625" cy="5670550"/>
   <p:notesSz cx="7559675" cy="10691813"/>
@@ -61,15 +60,15 @@
         <p:spPr>
           <a:xfrm>
             <a:off x="0" y="0"/>
-            <a:ext cx="4857840" cy="2877840"/>
+            <a:ext cx="4857480" cy="2877480"/>
           </a:xfrm>
           <a:custGeom>
             <a:avLst/>
             <a:gdLst>
-              <a:gd name="textAreaLeft" fmla="*/ 0 w 4857840"/>
-              <a:gd name="textAreaRight" fmla="*/ 4860360 w 4857840"/>
-              <a:gd name="textAreaTop" fmla="*/ 0 h 2877840"/>
-              <a:gd name="textAreaBottom" fmla="*/ 2880360 h 2877840"/>
+              <a:gd name="textAreaLeft" fmla="*/ 0 w 4857480"/>
+              <a:gd name="textAreaRight" fmla="*/ 4860360 w 4857480"/>
+              <a:gd name="textAreaTop" fmla="*/ 0 h 2877480"/>
+              <a:gd name="textAreaBottom" fmla="*/ 2880360 h 2877480"/>
             </a:gdLst>
             <a:ahLst/>
             <a:cxnLst/>
@@ -139,15 +138,15 @@
         <p:spPr>
           <a:xfrm>
             <a:off x="4320000" y="0"/>
-            <a:ext cx="5757840" cy="2157840"/>
+            <a:ext cx="5757480" cy="2157480"/>
           </a:xfrm>
           <a:custGeom>
             <a:avLst/>
             <a:gdLst>
-              <a:gd name="textAreaLeft" fmla="*/ 0 w 5757840"/>
-              <a:gd name="textAreaRight" fmla="*/ 5760360 w 5757840"/>
-              <a:gd name="textAreaTop" fmla="*/ 0 h 2157840"/>
-              <a:gd name="textAreaBottom" fmla="*/ 2160360 h 2157840"/>
+              <a:gd name="textAreaLeft" fmla="*/ 0 w 5757480"/>
+              <a:gd name="textAreaRight" fmla="*/ 5760360 w 5757480"/>
+              <a:gd name="textAreaTop" fmla="*/ 0 h 2157480"/>
+              <a:gd name="textAreaBottom" fmla="*/ 2160360 h 2157480"/>
             </a:gdLst>
             <a:ahLst/>
             <a:cxnLst/>
@@ -217,15 +216,15 @@
         <p:spPr>
           <a:xfrm>
             <a:off x="5580000" y="1260000"/>
-            <a:ext cx="4497840" cy="3777840"/>
+            <a:ext cx="4497480" cy="3777480"/>
           </a:xfrm>
           <a:custGeom>
             <a:avLst/>
             <a:gdLst>
-              <a:gd name="textAreaLeft" fmla="*/ 0 w 4497840"/>
-              <a:gd name="textAreaRight" fmla="*/ 4500360 w 4497840"/>
-              <a:gd name="textAreaTop" fmla="*/ 0 h 3777840"/>
-              <a:gd name="textAreaBottom" fmla="*/ 3780360 h 3777840"/>
+              <a:gd name="textAreaLeft" fmla="*/ 0 w 4497480"/>
+              <a:gd name="textAreaRight" fmla="*/ 4500360 w 4497480"/>
+              <a:gd name="textAreaTop" fmla="*/ 0 h 3777480"/>
+              <a:gd name="textAreaBottom" fmla="*/ 3780360 h 3777480"/>
             </a:gdLst>
             <a:ahLst/>
             <a:cxnLst/>
@@ -292,15 +291,15 @@
         <p:spPr>
           <a:xfrm>
             <a:off x="5580000" y="3060000"/>
-            <a:ext cx="4497840" cy="2607840"/>
+            <a:ext cx="4497480" cy="2607480"/>
           </a:xfrm>
           <a:custGeom>
             <a:avLst/>
             <a:gdLst>
-              <a:gd name="textAreaLeft" fmla="*/ 0 w 4497840"/>
-              <a:gd name="textAreaRight" fmla="*/ 4500360 w 4497840"/>
-              <a:gd name="textAreaTop" fmla="*/ 0 h 2607840"/>
-              <a:gd name="textAreaBottom" fmla="*/ 2610360 h 2607840"/>
+              <a:gd name="textAreaLeft" fmla="*/ 0 w 4497480"/>
+              <a:gd name="textAreaRight" fmla="*/ 4500360 w 4497480"/>
+              <a:gd name="textAreaTop" fmla="*/ 0 h 2607480"/>
+              <a:gd name="textAreaBottom" fmla="*/ 2610360 h 2607480"/>
             </a:gdLst>
             <a:ahLst/>
             <a:cxnLst/>
@@ -370,15 +369,15 @@
         <p:spPr>
           <a:xfrm>
             <a:off x="0" y="3762000"/>
-            <a:ext cx="5757840" cy="1905840"/>
+            <a:ext cx="5757480" cy="1905480"/>
           </a:xfrm>
           <a:custGeom>
             <a:avLst/>
             <a:gdLst>
-              <a:gd name="textAreaLeft" fmla="*/ 0 w 5757840"/>
-              <a:gd name="textAreaRight" fmla="*/ 5760360 w 5757840"/>
-              <a:gd name="textAreaTop" fmla="*/ 0 h 1905840"/>
-              <a:gd name="textAreaBottom" fmla="*/ 1908360 h 1905840"/>
+              <a:gd name="textAreaLeft" fmla="*/ 0 w 5757480"/>
+              <a:gd name="textAreaRight" fmla="*/ 5760360 w 5757480"/>
+              <a:gd name="textAreaTop" fmla="*/ 0 h 1905480"/>
+              <a:gd name="textAreaBottom" fmla="*/ 1908360 h 1905480"/>
             </a:gdLst>
             <a:ahLst/>
             <a:cxnLst/>
@@ -448,15 +447,15 @@
         <p:spPr>
           <a:xfrm>
             <a:off x="0" y="540000"/>
-            <a:ext cx="4317840" cy="3777840"/>
+            <a:ext cx="4317480" cy="3777480"/>
           </a:xfrm>
           <a:custGeom>
             <a:avLst/>
             <a:gdLst>
-              <a:gd name="textAreaLeft" fmla="*/ 0 w 4317840"/>
-              <a:gd name="textAreaRight" fmla="*/ 4320360 w 4317840"/>
-              <a:gd name="textAreaTop" fmla="*/ 0 h 3777840"/>
-              <a:gd name="textAreaBottom" fmla="*/ 3780360 h 3777840"/>
+              <a:gd name="textAreaLeft" fmla="*/ 0 w 4317480"/>
+              <a:gd name="textAreaRight" fmla="*/ 4320360 w 4317480"/>
+              <a:gd name="textAreaTop" fmla="*/ 0 h 3777480"/>
+              <a:gd name="textAreaBottom" fmla="*/ 3780360 h 3777480"/>
             </a:gdLst>
             <a:ahLst/>
             <a:cxnLst/>
@@ -527,7 +526,7 @@
         <p:spPr>
           <a:xfrm>
             <a:off x="360000" y="5220000"/>
-            <a:ext cx="2337480" cy="213840"/>
+            <a:ext cx="2337120" cy="213840"/>
           </a:xfrm>
           <a:prstGeom prst="rect">
             <a:avLst/>
@@ -607,7 +606,7 @@
         <p:spPr>
           <a:xfrm>
             <a:off x="3420000" y="5220000"/>
-            <a:ext cx="3237480" cy="213840"/>
+            <a:ext cx="3237120" cy="213840"/>
           </a:xfrm>
           <a:prstGeom prst="rect">
             <a:avLst/>
@@ -687,7 +686,7 @@
         <p:spPr>
           <a:xfrm>
             <a:off x="7380000" y="5220000"/>
-            <a:ext cx="2337480" cy="213840"/>
+            <a:ext cx="2337120" cy="213840"/>
           </a:xfrm>
           <a:prstGeom prst="rect">
             <a:avLst/>
@@ -731,7 +730,7 @@
                 <a:tab algn="l" pos="0"/>
               </a:tabLst>
             </a:pPr>
-            <a:fld id="{B6346526-8619-4ED9-92B6-A7DA6BE61774}" type="slidenum">
+            <a:fld id="{43E92566-4C2F-4C05-97BD-ACF74BE31E4C}" type="slidenum">
               <a:rPr b="0" lang="en-US" sz="1400" strike="noStrike" u="none">
                 <a:solidFill>
                   <a:srgbClr val="dddddd"/>
@@ -767,7 +766,7 @@
         <p:spPr>
           <a:xfrm>
             <a:off x="3780000" y="1980000"/>
-            <a:ext cx="2517480" cy="1797480"/>
+            <a:ext cx="2517120" cy="1797120"/>
           </a:xfrm>
           <a:prstGeom prst="rect">
             <a:avLst/>
@@ -809,9 +808,9 @@
               </a:rPr>
               <a:t>Click to edit the outline text format</a:t>
             </a:r>
-            <a:endParaRPr b="0" lang="en-US" sz="2400" strike="noStrike" u="none">
-              <a:solidFill>
-                <a:schemeClr val="dk1"/>
+            <a:endParaRPr b="0" lang="en-IN" sz="2400" strike="noStrike" u="none">
+              <a:solidFill>
+                <a:srgbClr val="000000"/>
               </a:solidFill>
               <a:effectLst/>
               <a:uFillTx/>
@@ -846,9 +845,9 @@
               </a:rPr>
               <a:t>Second Outline Level</a:t>
             </a:r>
-            <a:endParaRPr b="0" lang="en-US" sz="2200" strike="noStrike" u="none">
-              <a:solidFill>
-                <a:schemeClr val="dk1"/>
+            <a:endParaRPr b="0" lang="en-IN" sz="2200" strike="noStrike" u="none">
+              <a:solidFill>
+                <a:srgbClr val="000000"/>
               </a:solidFill>
               <a:effectLst/>
               <a:uFillTx/>
@@ -883,9 +882,9 @@
               </a:rPr>
               <a:t>Third Outline Level</a:t>
             </a:r>
-            <a:endParaRPr b="0" lang="en-US" sz="2000" strike="noStrike" u="none">
-              <a:solidFill>
-                <a:schemeClr val="dk1"/>
+            <a:endParaRPr b="0" lang="en-IN" sz="2000" strike="noStrike" u="none">
+              <a:solidFill>
+                <a:srgbClr val="000000"/>
               </a:solidFill>
               <a:effectLst/>
               <a:uFillTx/>
@@ -920,9 +919,9 @@
               </a:rPr>
               <a:t>Fourth Outline Level</a:t>
             </a:r>
-            <a:endParaRPr b="0" lang="en-US" sz="1800" strike="noStrike" u="none">
-              <a:solidFill>
-                <a:schemeClr val="dk1"/>
+            <a:endParaRPr b="0" lang="en-IN" sz="1800" strike="noStrike" u="none">
+              <a:solidFill>
+                <a:srgbClr val="000000"/>
               </a:solidFill>
               <a:effectLst/>
               <a:uFillTx/>
@@ -957,9 +956,9 @@
               </a:rPr>
               <a:t>Fifth Outline Level</a:t>
             </a:r>
-            <a:endParaRPr b="0" lang="en-US" sz="1600" strike="noStrike" u="none">
-              <a:solidFill>
-                <a:schemeClr val="dk1"/>
+            <a:endParaRPr b="0" lang="en-IN" sz="1600" strike="noStrike" u="none">
+              <a:solidFill>
+                <a:srgbClr val="000000"/>
               </a:solidFill>
               <a:effectLst/>
               <a:uFillTx/>
@@ -994,9 +993,9 @@
               </a:rPr>
               <a:t>Sixth Outline Level</a:t>
             </a:r>
-            <a:endParaRPr b="0" lang="en-US" sz="1400" strike="noStrike" u="none">
-              <a:solidFill>
-                <a:schemeClr val="dk1"/>
+            <a:endParaRPr b="0" lang="en-IN" sz="1400" strike="noStrike" u="none">
+              <a:solidFill>
+                <a:srgbClr val="000000"/>
               </a:solidFill>
               <a:effectLst/>
               <a:uFillTx/>
@@ -1031,9 +1030,9 @@
               </a:rPr>
               <a:t>Seventh Outline Level</a:t>
             </a:r>
-            <a:endParaRPr b="0" lang="en-US" sz="1400" strike="noStrike" u="none">
-              <a:solidFill>
-                <a:schemeClr val="dk1"/>
+            <a:endParaRPr b="0" lang="en-IN" sz="1400" strike="noStrike" u="none">
+              <a:solidFill>
+                <a:srgbClr val="000000"/>
               </a:solidFill>
               <a:effectLst/>
               <a:uFillTx/>
@@ -1055,7 +1054,7 @@
         <p:spPr>
           <a:xfrm>
             <a:off x="540000" y="180000"/>
-            <a:ext cx="3957480" cy="897480"/>
+            <a:ext cx="3957120" cy="897120"/>
           </a:xfrm>
           <a:prstGeom prst="rect">
             <a:avLst/>
@@ -1091,9 +1090,9 @@
               </a:rPr>
               <a:t>Click to edit the title text format</a:t>
             </a:r>
-            <a:endParaRPr b="0" lang="en-US" sz="3200" strike="noStrike" u="none">
-              <a:solidFill>
-                <a:schemeClr val="dk1"/>
+            <a:endParaRPr b="0" lang="en-IN" sz="3200" strike="noStrike" u="none">
+              <a:solidFill>
+                <a:srgbClr val="000000"/>
               </a:solidFill>
               <a:effectLst/>
               <a:uFillTx/>
@@ -1140,15 +1139,15 @@
         <p:spPr>
           <a:xfrm>
             <a:off x="0" y="0"/>
-            <a:ext cx="4857840" cy="2877840"/>
+            <a:ext cx="4857480" cy="2877480"/>
           </a:xfrm>
           <a:custGeom>
             <a:avLst/>
             <a:gdLst>
-              <a:gd name="textAreaLeft" fmla="*/ 0 w 4857840"/>
-              <a:gd name="textAreaRight" fmla="*/ 4860360 w 4857840"/>
-              <a:gd name="textAreaTop" fmla="*/ 0 h 2877840"/>
-              <a:gd name="textAreaBottom" fmla="*/ 2880360 h 2877840"/>
+              <a:gd name="textAreaLeft" fmla="*/ 0 w 4857480"/>
+              <a:gd name="textAreaRight" fmla="*/ 4860360 w 4857480"/>
+              <a:gd name="textAreaTop" fmla="*/ 0 h 2877480"/>
+              <a:gd name="textAreaBottom" fmla="*/ 2880360 h 2877480"/>
             </a:gdLst>
             <a:ahLst/>
             <a:cxnLst/>
@@ -1218,15 +1217,15 @@
         <p:spPr>
           <a:xfrm>
             <a:off x="4320000" y="0"/>
-            <a:ext cx="5757840" cy="2157840"/>
+            <a:ext cx="5757480" cy="2157480"/>
           </a:xfrm>
           <a:custGeom>
             <a:avLst/>
             <a:gdLst>
-              <a:gd name="textAreaLeft" fmla="*/ 0 w 5757840"/>
-              <a:gd name="textAreaRight" fmla="*/ 5760360 w 5757840"/>
-              <a:gd name="textAreaTop" fmla="*/ 0 h 2157840"/>
-              <a:gd name="textAreaBottom" fmla="*/ 2160360 h 2157840"/>
+              <a:gd name="textAreaLeft" fmla="*/ 0 w 5757480"/>
+              <a:gd name="textAreaRight" fmla="*/ 5760360 w 5757480"/>
+              <a:gd name="textAreaTop" fmla="*/ 0 h 2157480"/>
+              <a:gd name="textAreaBottom" fmla="*/ 2160360 h 2157480"/>
             </a:gdLst>
             <a:ahLst/>
             <a:cxnLst/>
@@ -1296,15 +1295,15 @@
         <p:spPr>
           <a:xfrm>
             <a:off x="5580000" y="1260000"/>
-            <a:ext cx="4497840" cy="3777840"/>
+            <a:ext cx="4497480" cy="3777480"/>
           </a:xfrm>
           <a:custGeom>
             <a:avLst/>
             <a:gdLst>
-              <a:gd name="textAreaLeft" fmla="*/ 0 w 4497840"/>
-              <a:gd name="textAreaRight" fmla="*/ 4500360 w 4497840"/>
-              <a:gd name="textAreaTop" fmla="*/ 0 h 3777840"/>
-              <a:gd name="textAreaBottom" fmla="*/ 3780360 h 3777840"/>
+              <a:gd name="textAreaLeft" fmla="*/ 0 w 4497480"/>
+              <a:gd name="textAreaRight" fmla="*/ 4500360 w 4497480"/>
+              <a:gd name="textAreaTop" fmla="*/ 0 h 3777480"/>
+              <a:gd name="textAreaBottom" fmla="*/ 3780360 h 3777480"/>
             </a:gdLst>
             <a:ahLst/>
             <a:cxnLst/>
@@ -1371,15 +1370,15 @@
         <p:spPr>
           <a:xfrm>
             <a:off x="5580000" y="3060000"/>
-            <a:ext cx="4497840" cy="2607840"/>
+            <a:ext cx="4497480" cy="2607480"/>
           </a:xfrm>
           <a:custGeom>
             <a:avLst/>
             <a:gdLst>
-              <a:gd name="textAreaLeft" fmla="*/ 0 w 4497840"/>
-              <a:gd name="textAreaRight" fmla="*/ 4500360 w 4497840"/>
-              <a:gd name="textAreaTop" fmla="*/ 0 h 2607840"/>
-              <a:gd name="textAreaBottom" fmla="*/ 2610360 h 2607840"/>
+              <a:gd name="textAreaLeft" fmla="*/ 0 w 4497480"/>
+              <a:gd name="textAreaRight" fmla="*/ 4500360 w 4497480"/>
+              <a:gd name="textAreaTop" fmla="*/ 0 h 2607480"/>
+              <a:gd name="textAreaBottom" fmla="*/ 2610360 h 2607480"/>
             </a:gdLst>
             <a:ahLst/>
             <a:cxnLst/>
@@ -1449,15 +1448,15 @@
         <p:spPr>
           <a:xfrm>
             <a:off x="0" y="3762000"/>
-            <a:ext cx="5757840" cy="1905840"/>
+            <a:ext cx="5757480" cy="1905480"/>
           </a:xfrm>
           <a:custGeom>
             <a:avLst/>
             <a:gdLst>
-              <a:gd name="textAreaLeft" fmla="*/ 0 w 5757840"/>
-              <a:gd name="textAreaRight" fmla="*/ 5760360 w 5757840"/>
-              <a:gd name="textAreaTop" fmla="*/ 0 h 1905840"/>
-              <a:gd name="textAreaBottom" fmla="*/ 1908360 h 1905840"/>
+              <a:gd name="textAreaLeft" fmla="*/ 0 w 5757480"/>
+              <a:gd name="textAreaRight" fmla="*/ 5760360 w 5757480"/>
+              <a:gd name="textAreaTop" fmla="*/ 0 h 1905480"/>
+              <a:gd name="textAreaBottom" fmla="*/ 1908360 h 1905480"/>
             </a:gdLst>
             <a:ahLst/>
             <a:cxnLst/>
@@ -1527,15 +1526,15 @@
         <p:spPr>
           <a:xfrm>
             <a:off x="0" y="540000"/>
-            <a:ext cx="4317840" cy="3777840"/>
+            <a:ext cx="4317480" cy="3777480"/>
           </a:xfrm>
           <a:custGeom>
             <a:avLst/>
             <a:gdLst>
-              <a:gd name="textAreaLeft" fmla="*/ 0 w 4317840"/>
-              <a:gd name="textAreaRight" fmla="*/ 4320360 w 4317840"/>
-              <a:gd name="textAreaTop" fmla="*/ 0 h 3777840"/>
-              <a:gd name="textAreaBottom" fmla="*/ 3780360 h 3777840"/>
+              <a:gd name="textAreaLeft" fmla="*/ 0 w 4317480"/>
+              <a:gd name="textAreaRight" fmla="*/ 4320360 w 4317480"/>
+              <a:gd name="textAreaTop" fmla="*/ 0 h 3777480"/>
+              <a:gd name="textAreaBottom" fmla="*/ 3780360 h 3777480"/>
             </a:gdLst>
             <a:ahLst/>
             <a:cxnLst/>
@@ -1606,7 +1605,7 @@
         <p:spPr>
           <a:xfrm>
             <a:off x="360000" y="5220000"/>
-            <a:ext cx="2337480" cy="213840"/>
+            <a:ext cx="2337120" cy="213840"/>
           </a:xfrm>
           <a:prstGeom prst="rect">
             <a:avLst/>
@@ -1686,7 +1685,7 @@
         <p:spPr>
           <a:xfrm>
             <a:off x="3420000" y="5220000"/>
-            <a:ext cx="3237480" cy="213840"/>
+            <a:ext cx="3237120" cy="213840"/>
           </a:xfrm>
           <a:prstGeom prst="rect">
             <a:avLst/>
@@ -1766,7 +1765,7 @@
         <p:spPr>
           <a:xfrm>
             <a:off x="7380000" y="5220000"/>
-            <a:ext cx="2337480" cy="213840"/>
+            <a:ext cx="2337120" cy="213840"/>
           </a:xfrm>
           <a:prstGeom prst="rect">
             <a:avLst/>
@@ -1810,7 +1809,7 @@
                 <a:tab algn="l" pos="0"/>
               </a:tabLst>
             </a:pPr>
-            <a:fld id="{80BB049E-545A-490C-97F4-94102CE6A9CC}" type="slidenum">
+            <a:fld id="{34323908-D2AA-45FB-BE89-4FBF6E39093A}" type="slidenum">
               <a:rPr b="0" lang="en-US" sz="1400" strike="noStrike" u="none">
                 <a:solidFill>
                   <a:srgbClr val="dddddd"/>
@@ -1846,7 +1845,7 @@
         <p:spPr>
           <a:xfrm>
             <a:off x="3780000" y="1980000"/>
-            <a:ext cx="2517480" cy="1797480"/>
+            <a:ext cx="2517120" cy="1797120"/>
           </a:xfrm>
           <a:prstGeom prst="rect">
             <a:avLst/>
@@ -1888,9 +1887,9 @@
               </a:rPr>
               <a:t>Click to edit the outline text format</a:t>
             </a:r>
-            <a:endParaRPr b="0" lang="en-US" sz="2400" strike="noStrike" u="none">
-              <a:solidFill>
-                <a:schemeClr val="dk1"/>
+            <a:endParaRPr b="0" lang="en-IN" sz="2400" strike="noStrike" u="none">
+              <a:solidFill>
+                <a:srgbClr val="000000"/>
               </a:solidFill>
               <a:effectLst/>
               <a:uFillTx/>
@@ -1925,9 +1924,9 @@
               </a:rPr>
               <a:t>Second Outline Level</a:t>
             </a:r>
-            <a:endParaRPr b="0" lang="en-US" sz="2200" strike="noStrike" u="none">
-              <a:solidFill>
-                <a:schemeClr val="dk1"/>
+            <a:endParaRPr b="0" lang="en-IN" sz="2200" strike="noStrike" u="none">
+              <a:solidFill>
+                <a:srgbClr val="000000"/>
               </a:solidFill>
               <a:effectLst/>
               <a:uFillTx/>
@@ -1962,9 +1961,9 @@
               </a:rPr>
               <a:t>Third Outline Level</a:t>
             </a:r>
-            <a:endParaRPr b="0" lang="en-US" sz="2000" strike="noStrike" u="none">
-              <a:solidFill>
-                <a:schemeClr val="dk1"/>
+            <a:endParaRPr b="0" lang="en-IN" sz="2000" strike="noStrike" u="none">
+              <a:solidFill>
+                <a:srgbClr val="000000"/>
               </a:solidFill>
               <a:effectLst/>
               <a:uFillTx/>
@@ -1999,9 +1998,9 @@
               </a:rPr>
               <a:t>Fourth Outline Level</a:t>
             </a:r>
-            <a:endParaRPr b="0" lang="en-US" sz="1800" strike="noStrike" u="none">
-              <a:solidFill>
-                <a:schemeClr val="dk1"/>
+            <a:endParaRPr b="0" lang="en-IN" sz="1800" strike="noStrike" u="none">
+              <a:solidFill>
+                <a:srgbClr val="000000"/>
               </a:solidFill>
               <a:effectLst/>
               <a:uFillTx/>
@@ -2036,9 +2035,9 @@
               </a:rPr>
               <a:t>Fifth Outline Level</a:t>
             </a:r>
-            <a:endParaRPr b="0" lang="en-US" sz="1600" strike="noStrike" u="none">
-              <a:solidFill>
-                <a:schemeClr val="dk1"/>
+            <a:endParaRPr b="0" lang="en-IN" sz="1600" strike="noStrike" u="none">
+              <a:solidFill>
+                <a:srgbClr val="000000"/>
               </a:solidFill>
               <a:effectLst/>
               <a:uFillTx/>
@@ -2073,9 +2072,9 @@
               </a:rPr>
               <a:t>Sixth Outline Level</a:t>
             </a:r>
-            <a:endParaRPr b="0" lang="en-US" sz="1400" strike="noStrike" u="none">
-              <a:solidFill>
-                <a:schemeClr val="dk1"/>
+            <a:endParaRPr b="0" lang="en-IN" sz="1400" strike="noStrike" u="none">
+              <a:solidFill>
+                <a:srgbClr val="000000"/>
               </a:solidFill>
               <a:effectLst/>
               <a:uFillTx/>
@@ -2110,9 +2109,9 @@
               </a:rPr>
               <a:t>Seventh Outline Level</a:t>
             </a:r>
-            <a:endParaRPr b="0" lang="en-US" sz="1400" strike="noStrike" u="none">
-              <a:solidFill>
-                <a:schemeClr val="dk1"/>
+            <a:endParaRPr b="0" lang="en-IN" sz="1400" strike="noStrike" u="none">
+              <a:solidFill>
+                <a:srgbClr val="000000"/>
               </a:solidFill>
               <a:effectLst/>
               <a:uFillTx/>
@@ -2134,7 +2133,7 @@
         <p:spPr>
           <a:xfrm>
             <a:off x="540000" y="180000"/>
-            <a:ext cx="3957480" cy="897480"/>
+            <a:ext cx="3957120" cy="897120"/>
           </a:xfrm>
           <a:prstGeom prst="rect">
             <a:avLst/>
@@ -2170,9 +2169,9 @@
               </a:rPr>
               <a:t>Click to edit the title text format</a:t>
             </a:r>
-            <a:endParaRPr b="0" lang="en-US" sz="3200" strike="noStrike" u="none">
-              <a:solidFill>
-                <a:schemeClr val="dk1"/>
+            <a:endParaRPr b="0" lang="en-IN" sz="3200" strike="noStrike" u="none">
+              <a:solidFill>
+                <a:srgbClr val="000000"/>
               </a:solidFill>
               <a:effectLst/>
               <a:uFillTx/>
@@ -2219,15 +2218,15 @@
         <p:spPr>
           <a:xfrm>
             <a:off x="0" y="0"/>
-            <a:ext cx="3273840" cy="3237840"/>
+            <a:ext cx="3273480" cy="3237480"/>
           </a:xfrm>
           <a:custGeom>
             <a:avLst/>
             <a:gdLst>
-              <a:gd name="textAreaLeft" fmla="*/ 0 w 3273840"/>
-              <a:gd name="textAreaRight" fmla="*/ 3276360 w 3273840"/>
-              <a:gd name="textAreaTop" fmla="*/ 0 h 3237840"/>
-              <a:gd name="textAreaBottom" fmla="*/ 3240360 h 3237840"/>
+              <a:gd name="textAreaLeft" fmla="*/ 0 w 3273480"/>
+              <a:gd name="textAreaRight" fmla="*/ 3276360 w 3273480"/>
+              <a:gd name="textAreaTop" fmla="*/ 0 h 3237480"/>
+              <a:gd name="textAreaBottom" fmla="*/ 3240360 h 3237480"/>
             </a:gdLst>
             <a:ahLst/>
             <a:cxnLst/>
@@ -2297,15 +2296,15 @@
         <p:spPr>
           <a:xfrm>
             <a:off x="3240000" y="0"/>
-            <a:ext cx="5397840" cy="1077840"/>
+            <a:ext cx="5397480" cy="1077480"/>
           </a:xfrm>
           <a:custGeom>
             <a:avLst/>
             <a:gdLst>
-              <a:gd name="textAreaLeft" fmla="*/ 0 w 5397840"/>
-              <a:gd name="textAreaRight" fmla="*/ 5400360 w 5397840"/>
-              <a:gd name="textAreaTop" fmla="*/ 0 h 1077840"/>
-              <a:gd name="textAreaBottom" fmla="*/ 1080360 h 1077840"/>
+              <a:gd name="textAreaLeft" fmla="*/ 0 w 5397480"/>
+              <a:gd name="textAreaRight" fmla="*/ 5400360 w 5397480"/>
+              <a:gd name="textAreaTop" fmla="*/ 0 h 1077480"/>
+              <a:gd name="textAreaBottom" fmla="*/ 1080360 h 1077480"/>
             </a:gdLst>
             <a:ahLst/>
             <a:cxnLst/>
@@ -2372,15 +2371,15 @@
         <p:spPr>
           <a:xfrm>
             <a:off x="6120000" y="0"/>
-            <a:ext cx="3957840" cy="3777840"/>
+            <a:ext cx="3957480" cy="3777480"/>
           </a:xfrm>
           <a:custGeom>
             <a:avLst/>
             <a:gdLst>
-              <a:gd name="textAreaLeft" fmla="*/ 0 w 3957840"/>
-              <a:gd name="textAreaRight" fmla="*/ 3960360 w 3957840"/>
-              <a:gd name="textAreaTop" fmla="*/ 0 h 3777840"/>
-              <a:gd name="textAreaBottom" fmla="*/ 3780360 h 3777840"/>
+              <a:gd name="textAreaLeft" fmla="*/ 0 w 3957480"/>
+              <a:gd name="textAreaRight" fmla="*/ 3960360 w 3957480"/>
+              <a:gd name="textAreaTop" fmla="*/ 0 h 3777480"/>
+              <a:gd name="textAreaBottom" fmla="*/ 3780360 h 3777480"/>
             </a:gdLst>
             <a:ahLst/>
             <a:cxnLst/>
@@ -2447,15 +2446,15 @@
         <p:spPr>
           <a:xfrm>
             <a:off x="6840000" y="2520000"/>
-            <a:ext cx="3237840" cy="3147840"/>
+            <a:ext cx="3237480" cy="3147480"/>
           </a:xfrm>
           <a:custGeom>
             <a:avLst/>
             <a:gdLst>
-              <a:gd name="textAreaLeft" fmla="*/ 0 w 3237840"/>
-              <a:gd name="textAreaRight" fmla="*/ 3240360 w 3237840"/>
-              <a:gd name="textAreaTop" fmla="*/ 0 h 3147840"/>
-              <a:gd name="textAreaBottom" fmla="*/ 3150360 h 3147840"/>
+              <a:gd name="textAreaLeft" fmla="*/ 0 w 3237480"/>
+              <a:gd name="textAreaRight" fmla="*/ 3240360 w 3237480"/>
+              <a:gd name="textAreaTop" fmla="*/ 0 h 3147480"/>
+              <a:gd name="textAreaBottom" fmla="*/ 3150360 h 3147480"/>
             </a:gdLst>
             <a:ahLst/>
             <a:cxnLst/>
@@ -2525,15 +2524,15 @@
         <p:spPr>
           <a:xfrm>
             <a:off x="1800000" y="4500000"/>
-            <a:ext cx="5037840" cy="1167840"/>
+            <a:ext cx="5037480" cy="1167480"/>
           </a:xfrm>
           <a:custGeom>
             <a:avLst/>
             <a:gdLst>
-              <a:gd name="textAreaLeft" fmla="*/ 0 w 5037840"/>
-              <a:gd name="textAreaRight" fmla="*/ 5040360 w 5037840"/>
-              <a:gd name="textAreaTop" fmla="*/ 0 h 1167840"/>
-              <a:gd name="textAreaBottom" fmla="*/ 1170360 h 1167840"/>
+              <a:gd name="textAreaLeft" fmla="*/ 0 w 5037480"/>
+              <a:gd name="textAreaRight" fmla="*/ 5040360 w 5037480"/>
+              <a:gd name="textAreaTop" fmla="*/ 0 h 1167480"/>
+              <a:gd name="textAreaBottom" fmla="*/ 1170360 h 1167480"/>
             </a:gdLst>
             <a:ahLst/>
             <a:cxnLst/>
@@ -2600,15 +2599,15 @@
         <p:spPr>
           <a:xfrm>
             <a:off x="0" y="2160000"/>
-            <a:ext cx="3993840" cy="3507840"/>
+            <a:ext cx="3993480" cy="3507480"/>
           </a:xfrm>
           <a:custGeom>
             <a:avLst/>
             <a:gdLst>
-              <a:gd name="textAreaLeft" fmla="*/ 0 w 3993840"/>
-              <a:gd name="textAreaRight" fmla="*/ 3996360 w 3993840"/>
-              <a:gd name="textAreaTop" fmla="*/ 0 h 3507840"/>
-              <a:gd name="textAreaBottom" fmla="*/ 3510360 h 3507840"/>
+              <a:gd name="textAreaLeft" fmla="*/ 0 w 3993480"/>
+              <a:gd name="textAreaRight" fmla="*/ 3996360 w 3993480"/>
+              <a:gd name="textAreaTop" fmla="*/ 0 h 3507480"/>
+              <a:gd name="textAreaBottom" fmla="*/ 3510360 h 3507480"/>
             </a:gdLst>
             <a:ahLst/>
             <a:cxnLst/>
@@ -2682,7 +2681,7 @@
         <p:spPr>
           <a:xfrm>
             <a:off x="360000" y="5220000"/>
-            <a:ext cx="2337480" cy="213840"/>
+            <a:ext cx="2337120" cy="213840"/>
           </a:xfrm>
           <a:prstGeom prst="rect">
             <a:avLst/>
@@ -2762,7 +2761,7 @@
         <p:spPr>
           <a:xfrm>
             <a:off x="3420000" y="5220000"/>
-            <a:ext cx="3237480" cy="213840"/>
+            <a:ext cx="3237120" cy="213840"/>
           </a:xfrm>
           <a:prstGeom prst="rect">
             <a:avLst/>
@@ -2842,7 +2841,7 @@
         <p:spPr>
           <a:xfrm>
             <a:off x="7380000" y="5220000"/>
-            <a:ext cx="2337480" cy="213840"/>
+            <a:ext cx="2337120" cy="213840"/>
           </a:xfrm>
           <a:prstGeom prst="rect">
             <a:avLst/>
@@ -2886,7 +2885,7 @@
                 <a:tab algn="l" pos="0"/>
               </a:tabLst>
             </a:pPr>
-            <a:fld id="{A7597B01-F332-4145-BA9C-D6C2C0E06FC6}" type="slidenum">
+            <a:fld id="{BE0779DA-4EAB-4C4D-A3FF-68DF6F555554}" type="slidenum">
               <a:rPr b="0" lang="en-US" sz="1400" strike="noStrike" u="none">
                 <a:solidFill>
                   <a:srgbClr val="dddddd"/>
@@ -2922,7 +2921,7 @@
         <p:spPr>
           <a:xfrm>
             <a:off x="2880000" y="900000"/>
-            <a:ext cx="4317480" cy="1077480"/>
+            <a:ext cx="4317120" cy="1077120"/>
           </a:xfrm>
           <a:prstGeom prst="rect">
             <a:avLst/>
@@ -2958,9 +2957,9 @@
               </a:rPr>
               <a:t>Click to edit the title text format</a:t>
             </a:r>
-            <a:endParaRPr b="0" lang="en-US" sz="3200" strike="noStrike" u="none">
-              <a:solidFill>
-                <a:schemeClr val="dk1"/>
+            <a:endParaRPr b="0" lang="en-IN" sz="3200" strike="noStrike" u="none">
+              <a:solidFill>
+                <a:srgbClr val="000000"/>
               </a:solidFill>
               <a:effectLst/>
               <a:uFillTx/>
@@ -2982,7 +2981,7 @@
         <p:spPr>
           <a:xfrm>
             <a:off x="2880000" y="2160000"/>
-            <a:ext cx="4317480" cy="2517480"/>
+            <a:ext cx="4317120" cy="2517120"/>
           </a:xfrm>
           <a:prstGeom prst="rect">
             <a:avLst/>
@@ -3026,9 +3025,9 @@
               </a:rPr>
               <a:t>Click to edit the outline text format</a:t>
             </a:r>
-            <a:endParaRPr b="0" lang="en-US" sz="2400" strike="noStrike" u="none">
-              <a:solidFill>
-                <a:schemeClr val="dk1"/>
+            <a:endParaRPr b="0" lang="en-IN" sz="2400" strike="noStrike" u="none">
+              <a:solidFill>
+                <a:srgbClr val="000000"/>
               </a:solidFill>
               <a:effectLst/>
               <a:uFillTx/>
@@ -3065,9 +3064,9 @@
               </a:rPr>
               <a:t>Second Outline Level</a:t>
             </a:r>
-            <a:endParaRPr b="0" lang="en-US" sz="2200" strike="noStrike" u="none">
-              <a:solidFill>
-                <a:schemeClr val="dk1"/>
+            <a:endParaRPr b="0" lang="en-IN" sz="2200" strike="noStrike" u="none">
+              <a:solidFill>
+                <a:srgbClr val="000000"/>
               </a:solidFill>
               <a:effectLst/>
               <a:uFillTx/>
@@ -3104,9 +3103,9 @@
               </a:rPr>
               <a:t>Third Outline Level</a:t>
             </a:r>
-            <a:endParaRPr b="0" lang="en-US" sz="2000" strike="noStrike" u="none">
-              <a:solidFill>
-                <a:schemeClr val="dk1"/>
+            <a:endParaRPr b="0" lang="en-IN" sz="2000" strike="noStrike" u="none">
+              <a:solidFill>
+                <a:srgbClr val="000000"/>
               </a:solidFill>
               <a:effectLst/>
               <a:uFillTx/>
@@ -3143,9 +3142,9 @@
               </a:rPr>
               <a:t>Fourth Outline Level</a:t>
             </a:r>
-            <a:endParaRPr b="0" lang="en-US" sz="1800" strike="noStrike" u="none">
-              <a:solidFill>
-                <a:schemeClr val="dk1"/>
+            <a:endParaRPr b="0" lang="en-IN" sz="1800" strike="noStrike" u="none">
+              <a:solidFill>
+                <a:srgbClr val="000000"/>
               </a:solidFill>
               <a:effectLst/>
               <a:uFillTx/>
@@ -3182,9 +3181,9 @@
               </a:rPr>
               <a:t>Fifth Outline Level</a:t>
             </a:r>
-            <a:endParaRPr b="0" lang="en-US" sz="1800" strike="noStrike" u="none">
-              <a:solidFill>
-                <a:schemeClr val="dk1"/>
+            <a:endParaRPr b="0" lang="en-IN" sz="1800" strike="noStrike" u="none">
+              <a:solidFill>
+                <a:srgbClr val="000000"/>
               </a:solidFill>
               <a:effectLst/>
               <a:uFillTx/>
@@ -3221,9 +3220,9 @@
               </a:rPr>
               <a:t>Sixth Outline Level</a:t>
             </a:r>
-            <a:endParaRPr b="0" lang="en-US" sz="1800" strike="noStrike" u="none">
-              <a:solidFill>
-                <a:schemeClr val="dk1"/>
+            <a:endParaRPr b="0" lang="en-IN" sz="1800" strike="noStrike" u="none">
+              <a:solidFill>
+                <a:srgbClr val="000000"/>
               </a:solidFill>
               <a:effectLst/>
               <a:uFillTx/>
@@ -3260,9 +3259,9 @@
               </a:rPr>
               <a:t>Seventh Outline Level</a:t>
             </a:r>
-            <a:endParaRPr b="0" lang="en-US" sz="1800" strike="noStrike" u="none">
-              <a:solidFill>
-                <a:schemeClr val="dk1"/>
+            <a:endParaRPr b="0" lang="en-IN" sz="1800" strike="noStrike" u="none">
+              <a:solidFill>
+                <a:srgbClr val="000000"/>
               </a:solidFill>
               <a:effectLst/>
               <a:uFillTx/>
@@ -3309,15 +3308,15 @@
         <p:spPr>
           <a:xfrm>
             <a:off x="0" y="0"/>
-            <a:ext cx="1977840" cy="3417840"/>
+            <a:ext cx="1977480" cy="3417480"/>
           </a:xfrm>
           <a:custGeom>
             <a:avLst/>
             <a:gdLst>
-              <a:gd name="textAreaLeft" fmla="*/ 0 w 1977840"/>
-              <a:gd name="textAreaRight" fmla="*/ 1980360 w 1977840"/>
-              <a:gd name="textAreaTop" fmla="*/ 0 h 3417840"/>
-              <a:gd name="textAreaBottom" fmla="*/ 3420360 h 3417840"/>
+              <a:gd name="textAreaLeft" fmla="*/ 0 w 1977480"/>
+              <a:gd name="textAreaRight" fmla="*/ 1980360 w 1977480"/>
+              <a:gd name="textAreaTop" fmla="*/ 0 h 3417480"/>
+              <a:gd name="textAreaBottom" fmla="*/ 3420360 h 3417480"/>
             </a:gdLst>
             <a:ahLst/>
             <a:cxnLst/>
@@ -3387,15 +3386,15 @@
         <p:spPr>
           <a:xfrm>
             <a:off x="2340000" y="0"/>
-            <a:ext cx="1977840" cy="357840"/>
+            <a:ext cx="1977480" cy="357480"/>
           </a:xfrm>
           <a:custGeom>
             <a:avLst/>
             <a:gdLst>
-              <a:gd name="textAreaLeft" fmla="*/ 0 w 1977840"/>
-              <a:gd name="textAreaRight" fmla="*/ 1980360 w 1977840"/>
-              <a:gd name="textAreaTop" fmla="*/ 0 h 357840"/>
-              <a:gd name="textAreaBottom" fmla="*/ 360360 h 357840"/>
+              <a:gd name="textAreaLeft" fmla="*/ 0 w 1977480"/>
+              <a:gd name="textAreaRight" fmla="*/ 1980360 w 1977480"/>
+              <a:gd name="textAreaTop" fmla="*/ 0 h 357480"/>
+              <a:gd name="textAreaBottom" fmla="*/ 360360 h 357480"/>
             </a:gdLst>
             <a:ahLst/>
             <a:cxnLst/>
@@ -3462,15 +3461,15 @@
         <p:spPr>
           <a:xfrm>
             <a:off x="6480000" y="0"/>
-            <a:ext cx="3597840" cy="2697840"/>
+            <a:ext cx="3597480" cy="2697480"/>
           </a:xfrm>
           <a:custGeom>
             <a:avLst/>
             <a:gdLst>
-              <a:gd name="textAreaLeft" fmla="*/ 0 w 3597840"/>
-              <a:gd name="textAreaRight" fmla="*/ 3600360 w 3597840"/>
-              <a:gd name="textAreaTop" fmla="*/ 0 h 2697840"/>
-              <a:gd name="textAreaBottom" fmla="*/ 2700360 h 2697840"/>
+              <a:gd name="textAreaLeft" fmla="*/ 0 w 3597480"/>
+              <a:gd name="textAreaRight" fmla="*/ 3600360 w 3597480"/>
+              <a:gd name="textAreaTop" fmla="*/ 0 h 2697480"/>
+              <a:gd name="textAreaBottom" fmla="*/ 2700360 h 2697480"/>
             </a:gdLst>
             <a:ahLst/>
             <a:cxnLst/>
@@ -3540,15 +3539,15 @@
         <p:spPr>
           <a:xfrm>
             <a:off x="8100000" y="2340000"/>
-            <a:ext cx="1977840" cy="3327840"/>
+            <a:ext cx="1977480" cy="3327480"/>
           </a:xfrm>
           <a:custGeom>
             <a:avLst/>
             <a:gdLst>
-              <a:gd name="textAreaLeft" fmla="*/ 0 w 1977840"/>
-              <a:gd name="textAreaRight" fmla="*/ 1980360 w 1977840"/>
-              <a:gd name="textAreaTop" fmla="*/ 0 h 3327840"/>
-              <a:gd name="textAreaBottom" fmla="*/ 3330360 h 3327840"/>
+              <a:gd name="textAreaLeft" fmla="*/ 0 w 1977480"/>
+              <a:gd name="textAreaRight" fmla="*/ 1980360 w 1977480"/>
+              <a:gd name="textAreaTop" fmla="*/ 0 h 3327480"/>
+              <a:gd name="textAreaBottom" fmla="*/ 3330360 h 3327480"/>
             </a:gdLst>
             <a:ahLst/>
             <a:cxnLst/>
@@ -3618,15 +3617,15 @@
         <p:spPr>
           <a:xfrm>
             <a:off x="5940000" y="5220000"/>
-            <a:ext cx="1797480" cy="447840"/>
+            <a:ext cx="1797120" cy="447480"/>
           </a:xfrm>
           <a:custGeom>
             <a:avLst/>
             <a:gdLst>
-              <a:gd name="textAreaLeft" fmla="*/ 0 w 1797480"/>
-              <a:gd name="textAreaRight" fmla="*/ 1800000 w 1797480"/>
-              <a:gd name="textAreaTop" fmla="*/ 0 h 447840"/>
-              <a:gd name="textAreaBottom" fmla="*/ 450360 h 447840"/>
+              <a:gd name="textAreaLeft" fmla="*/ 0 w 1797120"/>
+              <a:gd name="textAreaRight" fmla="*/ 1800000 w 1797120"/>
+              <a:gd name="textAreaTop" fmla="*/ 0 h 447480"/>
+              <a:gd name="textAreaBottom" fmla="*/ 450360 h 447480"/>
             </a:gdLst>
             <a:ahLst/>
             <a:cxnLst/>
@@ -3693,15 +3692,15 @@
         <p:spPr>
           <a:xfrm>
             <a:off x="0" y="3240000"/>
-            <a:ext cx="3237840" cy="2427840"/>
+            <a:ext cx="3237480" cy="2427480"/>
           </a:xfrm>
           <a:custGeom>
             <a:avLst/>
             <a:gdLst>
-              <a:gd name="textAreaLeft" fmla="*/ 0 w 3237840"/>
-              <a:gd name="textAreaRight" fmla="*/ 3240360 w 3237840"/>
-              <a:gd name="textAreaTop" fmla="*/ 0 h 2427840"/>
-              <a:gd name="textAreaBottom" fmla="*/ 2430360 h 2427840"/>
+              <a:gd name="textAreaLeft" fmla="*/ 0 w 3237480"/>
+              <a:gd name="textAreaRight" fmla="*/ 3240360 w 3237480"/>
+              <a:gd name="textAreaTop" fmla="*/ 0 h 2427480"/>
+              <a:gd name="textAreaBottom" fmla="*/ 2430360 h 2427480"/>
             </a:gdLst>
             <a:ahLst/>
             <a:cxnLst/>
@@ -3772,7 +3771,7 @@
         <p:spPr>
           <a:xfrm>
             <a:off x="1800000" y="360000"/>
-            <a:ext cx="6477480" cy="897480"/>
+            <a:ext cx="6477120" cy="897120"/>
           </a:xfrm>
           <a:prstGeom prst="rect">
             <a:avLst/>
@@ -3808,9 +3807,9 @@
               </a:rPr>
               <a:t>Click to edit the title text format</a:t>
             </a:r>
-            <a:endParaRPr b="0" lang="en-US" sz="3200" strike="noStrike" u="none">
-              <a:solidFill>
-                <a:schemeClr val="dk1"/>
+            <a:endParaRPr b="0" lang="en-IN" sz="3200" strike="noStrike" u="none">
+              <a:solidFill>
+                <a:srgbClr val="000000"/>
               </a:solidFill>
               <a:effectLst/>
               <a:uFillTx/>
@@ -3832,7 +3831,7 @@
         <p:spPr>
           <a:xfrm>
             <a:off x="1800000" y="1440000"/>
-            <a:ext cx="6477480" cy="3597480"/>
+            <a:ext cx="6477120" cy="3597120"/>
           </a:xfrm>
           <a:prstGeom prst="rect">
             <a:avLst/>
@@ -3876,9 +3875,9 @@
               </a:rPr>
               <a:t>Click to edit the outline text format</a:t>
             </a:r>
-            <a:endParaRPr b="0" lang="en-US" sz="2400" strike="noStrike" u="none">
-              <a:solidFill>
-                <a:schemeClr val="dk1"/>
+            <a:endParaRPr b="0" lang="en-IN" sz="2400" strike="noStrike" u="none">
+              <a:solidFill>
+                <a:srgbClr val="000000"/>
               </a:solidFill>
               <a:effectLst/>
               <a:uFillTx/>
@@ -3915,9 +3914,9 @@
               </a:rPr>
               <a:t>Second Outline Level</a:t>
             </a:r>
-            <a:endParaRPr b="0" lang="en-US" sz="2200" strike="noStrike" u="none">
-              <a:solidFill>
-                <a:schemeClr val="dk1"/>
+            <a:endParaRPr b="0" lang="en-IN" sz="2200" strike="noStrike" u="none">
+              <a:solidFill>
+                <a:srgbClr val="000000"/>
               </a:solidFill>
               <a:effectLst/>
               <a:uFillTx/>
@@ -3954,9 +3953,9 @@
               </a:rPr>
               <a:t>Third Outline Level</a:t>
             </a:r>
-            <a:endParaRPr b="0" lang="en-US" sz="2000" strike="noStrike" u="none">
-              <a:solidFill>
-                <a:schemeClr val="dk1"/>
+            <a:endParaRPr b="0" lang="en-IN" sz="2000" strike="noStrike" u="none">
+              <a:solidFill>
+                <a:srgbClr val="000000"/>
               </a:solidFill>
               <a:effectLst/>
               <a:uFillTx/>
@@ -3993,9 +3992,9 @@
               </a:rPr>
               <a:t>Fourth Outline Level</a:t>
             </a:r>
-            <a:endParaRPr b="0" lang="en-US" sz="1800" strike="noStrike" u="none">
-              <a:solidFill>
-                <a:schemeClr val="dk1"/>
+            <a:endParaRPr b="0" lang="en-IN" sz="1800" strike="noStrike" u="none">
+              <a:solidFill>
+                <a:srgbClr val="000000"/>
               </a:solidFill>
               <a:effectLst/>
               <a:uFillTx/>
@@ -4032,9 +4031,9 @@
               </a:rPr>
               <a:t>Fifth Outline Level</a:t>
             </a:r>
-            <a:endParaRPr b="0" lang="en-US" sz="1600" strike="noStrike" u="none">
-              <a:solidFill>
-                <a:schemeClr val="dk1"/>
+            <a:endParaRPr b="0" lang="en-IN" sz="1600" strike="noStrike" u="none">
+              <a:solidFill>
+                <a:srgbClr val="000000"/>
               </a:solidFill>
               <a:effectLst/>
               <a:uFillTx/>
@@ -4071,9 +4070,9 @@
               </a:rPr>
               <a:t>Sixth Outline Level</a:t>
             </a:r>
-            <a:endParaRPr b="0" lang="en-US" sz="1600" strike="noStrike" u="none">
-              <a:solidFill>
-                <a:schemeClr val="dk1"/>
+            <a:endParaRPr b="0" lang="en-IN" sz="1600" strike="noStrike" u="none">
+              <a:solidFill>
+                <a:srgbClr val="000000"/>
               </a:solidFill>
               <a:effectLst/>
               <a:uFillTx/>
@@ -4110,9 +4109,9 @@
               </a:rPr>
               <a:t>Seventh Outline Level</a:t>
             </a:r>
-            <a:endParaRPr b="0" lang="en-US" sz="1600" strike="noStrike" u="none">
-              <a:solidFill>
-                <a:schemeClr val="dk1"/>
+            <a:endParaRPr b="0" lang="en-IN" sz="1600" strike="noStrike" u="none">
+              <a:solidFill>
+                <a:srgbClr val="000000"/>
               </a:solidFill>
               <a:effectLst/>
               <a:uFillTx/>
@@ -4134,7 +4133,7 @@
         <p:spPr>
           <a:xfrm>
             <a:off x="360000" y="5220000"/>
-            <a:ext cx="2337480" cy="213840"/>
+            <a:ext cx="2337120" cy="213840"/>
           </a:xfrm>
           <a:prstGeom prst="rect">
             <a:avLst/>
@@ -4214,7 +4213,7 @@
         <p:spPr>
           <a:xfrm>
             <a:off x="3420000" y="5220000"/>
-            <a:ext cx="3237480" cy="213840"/>
+            <a:ext cx="3237120" cy="213840"/>
           </a:xfrm>
           <a:prstGeom prst="rect">
             <a:avLst/>
@@ -4294,7 +4293,7 @@
         <p:spPr>
           <a:xfrm>
             <a:off x="7380000" y="5220000"/>
-            <a:ext cx="2337480" cy="213840"/>
+            <a:ext cx="2337120" cy="213840"/>
           </a:xfrm>
           <a:prstGeom prst="rect">
             <a:avLst/>
@@ -4338,7 +4337,7 @@
                 <a:tab algn="l" pos="0"/>
               </a:tabLst>
             </a:pPr>
-            <a:fld id="{73C617D5-84DF-4DE8-9B85-E753BFAB41F7}" type="slidenum">
+            <a:fld id="{5D5658B5-AABB-44D8-8205-35FDA6FA714D}" type="slidenum">
               <a:rPr b="0" lang="en-US" sz="1400" strike="noStrike" u="none">
                 <a:solidFill>
                   <a:srgbClr val="dddddd"/>
@@ -4399,15 +4398,15 @@
         <p:spPr>
           <a:xfrm>
             <a:off x="0" y="0"/>
-            <a:ext cx="1077840" cy="3417840"/>
+            <a:ext cx="1077480" cy="3417480"/>
           </a:xfrm>
           <a:custGeom>
             <a:avLst/>
             <a:gdLst>
-              <a:gd name="textAreaLeft" fmla="*/ 0 w 1077840"/>
-              <a:gd name="textAreaRight" fmla="*/ 1080360 w 1077840"/>
-              <a:gd name="textAreaTop" fmla="*/ 0 h 3417840"/>
-              <a:gd name="textAreaBottom" fmla="*/ 3420360 h 3417840"/>
+              <a:gd name="textAreaLeft" fmla="*/ 0 w 1077480"/>
+              <a:gd name="textAreaRight" fmla="*/ 1080360 w 1077480"/>
+              <a:gd name="textAreaTop" fmla="*/ 0 h 3417480"/>
+              <a:gd name="textAreaBottom" fmla="*/ 3420360 h 3417480"/>
             </a:gdLst>
             <a:ahLst/>
             <a:cxnLst/>
@@ -4474,15 +4473,15 @@
         <p:spPr>
           <a:xfrm>
             <a:off x="7740000" y="0"/>
-            <a:ext cx="2337840" cy="1617840"/>
+            <a:ext cx="2337480" cy="1617480"/>
           </a:xfrm>
           <a:custGeom>
             <a:avLst/>
             <a:gdLst>
-              <a:gd name="textAreaLeft" fmla="*/ 0 w 2337840"/>
-              <a:gd name="textAreaRight" fmla="*/ 2340360 w 2337840"/>
-              <a:gd name="textAreaTop" fmla="*/ 0 h 1617840"/>
-              <a:gd name="textAreaBottom" fmla="*/ 1620360 h 1617840"/>
+              <a:gd name="textAreaLeft" fmla="*/ 0 w 2337480"/>
+              <a:gd name="textAreaRight" fmla="*/ 2340360 w 2337480"/>
+              <a:gd name="textAreaTop" fmla="*/ 0 h 1617480"/>
+              <a:gd name="textAreaBottom" fmla="*/ 1620360 h 1617480"/>
             </a:gdLst>
             <a:ahLst/>
             <a:cxnLst/>
@@ -4549,15 +4548,15 @@
         <p:spPr>
           <a:xfrm>
             <a:off x="9000000" y="2520000"/>
-            <a:ext cx="1077840" cy="3147840"/>
+            <a:ext cx="1077480" cy="3147480"/>
           </a:xfrm>
           <a:custGeom>
             <a:avLst/>
             <a:gdLst>
-              <a:gd name="textAreaLeft" fmla="*/ 0 w 1077840"/>
-              <a:gd name="textAreaRight" fmla="*/ 1080360 w 1077840"/>
-              <a:gd name="textAreaTop" fmla="*/ 0 h 3147840"/>
-              <a:gd name="textAreaBottom" fmla="*/ 3150360 h 3147840"/>
+              <a:gd name="textAreaLeft" fmla="*/ 0 w 1077480"/>
+              <a:gd name="textAreaRight" fmla="*/ 1080360 w 1077480"/>
+              <a:gd name="textAreaTop" fmla="*/ 0 h 3147480"/>
+              <a:gd name="textAreaBottom" fmla="*/ 3150360 h 3147480"/>
             </a:gdLst>
             <a:ahLst/>
             <a:cxnLst/>
@@ -4624,15 +4623,15 @@
         <p:spPr>
           <a:xfrm>
             <a:off x="0" y="4320000"/>
-            <a:ext cx="1977840" cy="1347840"/>
+            <a:ext cx="1977480" cy="1347480"/>
           </a:xfrm>
           <a:custGeom>
             <a:avLst/>
             <a:gdLst>
-              <a:gd name="textAreaLeft" fmla="*/ 0 w 1977840"/>
-              <a:gd name="textAreaRight" fmla="*/ 1980360 w 1977840"/>
-              <a:gd name="textAreaTop" fmla="*/ 0 h 1347840"/>
-              <a:gd name="textAreaBottom" fmla="*/ 1350360 h 1347840"/>
+              <a:gd name="textAreaLeft" fmla="*/ 0 w 1977480"/>
+              <a:gd name="textAreaRight" fmla="*/ 1980360 w 1977480"/>
+              <a:gd name="textAreaTop" fmla="*/ 0 h 1347480"/>
+              <a:gd name="textAreaBottom" fmla="*/ 1350360 h 1347480"/>
             </a:gdLst>
             <a:ahLst/>
             <a:cxnLst/>
@@ -4703,7 +4702,7 @@
         <p:spPr>
           <a:xfrm>
             <a:off x="360000" y="5220000"/>
-            <a:ext cx="2337480" cy="213840"/>
+            <a:ext cx="2337120" cy="213840"/>
           </a:xfrm>
           <a:prstGeom prst="rect">
             <a:avLst/>
@@ -4783,7 +4782,7 @@
         <p:spPr>
           <a:xfrm>
             <a:off x="3420000" y="5220000"/>
-            <a:ext cx="3237480" cy="213840"/>
+            <a:ext cx="3237120" cy="213840"/>
           </a:xfrm>
           <a:prstGeom prst="rect">
             <a:avLst/>
@@ -4863,7 +4862,7 @@
         <p:spPr>
           <a:xfrm>
             <a:off x="7380000" y="5220000"/>
-            <a:ext cx="2337480" cy="213840"/>
+            <a:ext cx="2337120" cy="213840"/>
           </a:xfrm>
           <a:prstGeom prst="rect">
             <a:avLst/>
@@ -4907,7 +4906,7 @@
                 <a:tab algn="l" pos="0"/>
               </a:tabLst>
             </a:pPr>
-            <a:fld id="{419BF9A9-E3C2-41A5-81D6-68BEB2BB50B4}" type="slidenum">
+            <a:fld id="{A6FDDBAE-B614-47D1-B52C-28328ADBE7A4}" type="slidenum">
               <a:rPr b="0" lang="en-US" sz="1400" strike="noStrike" u="none">
                 <a:solidFill>
                   <a:srgbClr val="dddddd"/>
@@ -4943,7 +4942,7 @@
         <p:spPr>
           <a:xfrm>
             <a:off x="720000" y="360000"/>
-            <a:ext cx="8637480" cy="897480"/>
+            <a:ext cx="8637120" cy="897120"/>
           </a:xfrm>
           <a:prstGeom prst="rect">
             <a:avLst/>
@@ -4979,9 +4978,9 @@
               </a:rPr>
               <a:t>Click to edit the title text format</a:t>
             </a:r>
-            <a:endParaRPr b="0" lang="en-US" sz="3200" strike="noStrike" u="none">
-              <a:solidFill>
-                <a:schemeClr val="dk1"/>
+            <a:endParaRPr b="0" lang="en-IN" sz="3200" strike="noStrike" u="none">
+              <a:solidFill>
+                <a:srgbClr val="000000"/>
               </a:solidFill>
               <a:effectLst/>
               <a:uFillTx/>
@@ -5003,7 +5002,7 @@
         <p:spPr>
           <a:xfrm>
             <a:off x="720000" y="1440000"/>
-            <a:ext cx="8637480" cy="3597480"/>
+            <a:ext cx="8637120" cy="3597120"/>
           </a:xfrm>
           <a:prstGeom prst="rect">
             <a:avLst/>
@@ -5047,9 +5046,9 @@
               </a:rPr>
               <a:t>Click to edit the outline text format</a:t>
             </a:r>
-            <a:endParaRPr b="0" lang="en-US" sz="2400" strike="noStrike" u="none">
-              <a:solidFill>
-                <a:schemeClr val="dk1"/>
+            <a:endParaRPr b="0" lang="en-IN" sz="2400" strike="noStrike" u="none">
+              <a:solidFill>
+                <a:srgbClr val="000000"/>
               </a:solidFill>
               <a:effectLst/>
               <a:uFillTx/>
@@ -5086,9 +5085,9 @@
               </a:rPr>
               <a:t>Second Outline Level</a:t>
             </a:r>
-            <a:endParaRPr b="0" lang="en-US" sz="2200" strike="noStrike" u="none">
-              <a:solidFill>
-                <a:schemeClr val="dk1"/>
+            <a:endParaRPr b="0" lang="en-IN" sz="2200" strike="noStrike" u="none">
+              <a:solidFill>
+                <a:srgbClr val="000000"/>
               </a:solidFill>
               <a:effectLst/>
               <a:uFillTx/>
@@ -5125,9 +5124,9 @@
               </a:rPr>
               <a:t>Third Outline Level</a:t>
             </a:r>
-            <a:endParaRPr b="0" lang="en-US" sz="2000" strike="noStrike" u="none">
-              <a:solidFill>
-                <a:schemeClr val="dk1"/>
+            <a:endParaRPr b="0" lang="en-IN" sz="2000" strike="noStrike" u="none">
+              <a:solidFill>
+                <a:srgbClr val="000000"/>
               </a:solidFill>
               <a:effectLst/>
               <a:uFillTx/>
@@ -5164,9 +5163,9 @@
               </a:rPr>
               <a:t>Fourth Outline Level</a:t>
             </a:r>
-            <a:endParaRPr b="0" lang="en-US" sz="1800" strike="noStrike" u="none">
-              <a:solidFill>
-                <a:schemeClr val="dk1"/>
+            <a:endParaRPr b="0" lang="en-IN" sz="1800" strike="noStrike" u="none">
+              <a:solidFill>
+                <a:srgbClr val="000000"/>
               </a:solidFill>
               <a:effectLst/>
               <a:uFillTx/>
@@ -5203,9 +5202,9 @@
               </a:rPr>
               <a:t>Fifth Outline Level</a:t>
             </a:r>
-            <a:endParaRPr b="0" lang="en-US" sz="1800" strike="noStrike" u="none">
-              <a:solidFill>
-                <a:schemeClr val="dk1"/>
+            <a:endParaRPr b="0" lang="en-IN" sz="1800" strike="noStrike" u="none">
+              <a:solidFill>
+                <a:srgbClr val="000000"/>
               </a:solidFill>
               <a:effectLst/>
               <a:uFillTx/>
@@ -5242,9 +5241,9 @@
               </a:rPr>
               <a:t>Sixth Outline Level</a:t>
             </a:r>
-            <a:endParaRPr b="0" lang="en-US" sz="1800" strike="noStrike" u="none">
-              <a:solidFill>
-                <a:schemeClr val="dk1"/>
+            <a:endParaRPr b="0" lang="en-IN" sz="1800" strike="noStrike" u="none">
+              <a:solidFill>
+                <a:srgbClr val="000000"/>
               </a:solidFill>
               <a:effectLst/>
               <a:uFillTx/>
@@ -5281,9 +5280,9 @@
               </a:rPr>
               <a:t>Seventh Outline Level</a:t>
             </a:r>
-            <a:endParaRPr b="0" lang="en-US" sz="1800" strike="noStrike" u="none">
-              <a:solidFill>
-                <a:schemeClr val="dk1"/>
+            <a:endParaRPr b="0" lang="en-IN" sz="1800" strike="noStrike" u="none">
+              <a:solidFill>
+                <a:srgbClr val="000000"/>
               </a:solidFill>
               <a:effectLst/>
               <a:uFillTx/>
@@ -5356,8 +5355,8 @@
         </p:nvSpPr>
         <p:spPr>
           <a:xfrm>
-            <a:off x="1765080" y="362160"/>
-            <a:ext cx="6590160" cy="671400"/>
+            <a:off x="1765080" y="361800"/>
+            <a:ext cx="6589800" cy="671760"/>
           </a:xfrm>
           <a:prstGeom prst="rect">
             <a:avLst/>
@@ -5393,9 +5392,9 @@
               </a:rPr>
               <a:t>Project Title</a:t>
             </a:r>
-            <a:endParaRPr b="0" lang="en-US" sz="3200" strike="noStrike" u="none">
-              <a:solidFill>
-                <a:schemeClr val="dk1"/>
+            <a:endParaRPr b="0" lang="en-IN" sz="3200" strike="noStrike" u="none">
+              <a:solidFill>
+                <a:srgbClr val="000000"/>
               </a:solidFill>
               <a:effectLst/>
               <a:uFillTx/>
@@ -5417,7 +5416,7 @@
         <p:spPr>
           <a:xfrm>
             <a:off x="375120" y="1172520"/>
-            <a:ext cx="9370080" cy="4158720"/>
+            <a:ext cx="9369720" cy="4158360"/>
           </a:xfrm>
           <a:prstGeom prst="rect">
             <a:avLst/>
@@ -5456,9 +5455,9 @@
               </a:rPr>
               <a:t>Urban Ride : Online Car Rental Management System</a:t>
             </a:r>
-            <a:endParaRPr b="0" lang="en-US" sz="2400" strike="noStrike" u="none">
-              <a:solidFill>
-                <a:schemeClr val="dk1"/>
+            <a:endParaRPr b="0" lang="en-IN" sz="2400" strike="noStrike" u="none">
+              <a:solidFill>
+                <a:srgbClr val="000000"/>
               </a:solidFill>
               <a:effectLst/>
               <a:uFillTx/>
@@ -5478,9 +5477,9 @@
                 <a:tab algn="l" pos="0"/>
               </a:tabLst>
             </a:pPr>
-            <a:endParaRPr b="0" lang="en-US" sz="2400" strike="noStrike" u="none">
-              <a:solidFill>
-                <a:schemeClr val="dk1"/>
+            <a:endParaRPr b="0" lang="en-IN" sz="2400" strike="noStrike" u="none">
+              <a:solidFill>
+                <a:srgbClr val="000000"/>
               </a:solidFill>
               <a:effectLst/>
               <a:uFillTx/>
@@ -5512,9 +5511,9 @@
               </a:rPr>
               <a:t>Members:</a:t>
             </a:r>
-            <a:endParaRPr b="0" lang="en-US" sz="2400" strike="noStrike" u="none">
-              <a:solidFill>
-                <a:schemeClr val="dk1"/>
+            <a:endParaRPr b="0" lang="en-IN" sz="2400" strike="noStrike" u="none">
+              <a:solidFill>
+                <a:srgbClr val="000000"/>
               </a:solidFill>
               <a:effectLst/>
               <a:uFillTx/>
@@ -5546,9 +5545,9 @@
               </a:rPr>
               <a:t>   1426 : Ikrama Kathiyara</a:t>
             </a:r>
-            <a:endParaRPr b="0" lang="en-US" sz="2400" strike="noStrike" u="none">
-              <a:solidFill>
-                <a:schemeClr val="dk1"/>
+            <a:endParaRPr b="0" lang="en-IN" sz="2400" strike="noStrike" u="none">
+              <a:solidFill>
+                <a:srgbClr val="000000"/>
               </a:solidFill>
               <a:effectLst/>
               <a:uFillTx/>
@@ -5580,9 +5579,9 @@
               </a:rPr>
               <a:t>1437 : Rudra Padhiyar</a:t>
             </a:r>
-            <a:endParaRPr b="0" lang="en-US" sz="2400" strike="noStrike" u="none">
-              <a:solidFill>
-                <a:schemeClr val="dk1"/>
+            <a:endParaRPr b="0" lang="en-IN" sz="2400" strike="noStrike" u="none">
+              <a:solidFill>
+                <a:srgbClr val="000000"/>
               </a:solidFill>
               <a:effectLst/>
               <a:uFillTx/>
@@ -5614,9 +5613,9 @@
               </a:rPr>
               <a:t>1452 : Fahad Shaikh   </a:t>
             </a:r>
-            <a:endParaRPr b="0" lang="en-US" sz="2400" strike="noStrike" u="none">
-              <a:solidFill>
-                <a:schemeClr val="dk1"/>
+            <a:endParaRPr b="0" lang="en-IN" sz="2400" strike="noStrike" u="none">
+              <a:solidFill>
+                <a:srgbClr val="000000"/>
               </a:solidFill>
               <a:effectLst/>
               <a:uFillTx/>
@@ -5636,9 +5635,9 @@
                 <a:tab algn="l" pos="0"/>
               </a:tabLst>
             </a:pPr>
-            <a:endParaRPr b="0" lang="en-US" sz="2400" strike="noStrike" u="none">
-              <a:solidFill>
-                <a:schemeClr val="dk1"/>
+            <a:endParaRPr b="0" lang="en-IN" sz="2400" strike="noStrike" u="none">
+              <a:solidFill>
+                <a:srgbClr val="000000"/>
               </a:solidFill>
               <a:effectLst/>
               <a:uFillTx/>
@@ -5670,9 +5669,9 @@
               </a:rPr>
               <a:t>Mentor: Prof. Shreyas Trivedi</a:t>
             </a:r>
-            <a:endParaRPr b="0" lang="en-US" sz="2400" strike="noStrike" u="none">
-              <a:solidFill>
-                <a:schemeClr val="dk1"/>
+            <a:endParaRPr b="0" lang="en-IN" sz="2400" strike="noStrike" u="none">
+              <a:solidFill>
+                <a:srgbClr val="000000"/>
               </a:solidFill>
               <a:effectLst/>
               <a:uFillTx/>
@@ -5695,7 +5694,7 @@
         <p:txBody>
           <a:bodyPr/>
           <a:p>
-            <a:fld id="{AEA1600D-A20A-41F4-9268-F276D8946AE1}" type="slidenum">
+            <a:fld id="{6FE677F0-179B-4A17-B5B4-9A4F9A347A0F}" type="slidenum">
               <a:t>1</a:t>
             </a:fld>
           </a:p>
@@ -5743,8 +5742,8 @@
         </p:nvSpPr>
         <p:spPr>
           <a:xfrm>
-            <a:off x="914400" y="-216000"/>
-            <a:ext cx="8637480" cy="901800"/>
+            <a:off x="914400" y="-216360"/>
+            <a:ext cx="8637120" cy="902160"/>
           </a:xfrm>
           <a:prstGeom prst="rect">
             <a:avLst/>
@@ -5780,9 +5779,9 @@
               </a:rPr>
               <a:t>Use-Case Diagram</a:t>
             </a:r>
-            <a:endParaRPr b="0" lang="en-US" sz="3200" strike="noStrike" u="none">
-              <a:solidFill>
-                <a:schemeClr val="dk1"/>
+            <a:endParaRPr b="0" lang="en-IN" sz="3200" strike="noStrike" u="none">
+              <a:solidFill>
+                <a:srgbClr val="000000"/>
               </a:solidFill>
               <a:effectLst/>
               <a:uFillTx/>
@@ -5805,7 +5804,7 @@
         <p:spPr>
           <a:xfrm>
             <a:off x="2286360" y="501840"/>
-            <a:ext cx="4798800" cy="4992480"/>
+            <a:ext cx="4798440" cy="4992120"/>
           </a:xfrm>
           <a:prstGeom prst="rect">
             <a:avLst/>
@@ -5830,7 +5829,7 @@
         <p:txBody>
           <a:bodyPr/>
           <a:p>
-            <a:fld id="{25B2FD02-5DB0-4B66-B2E9-9EFA0B33AC40}" type="slidenum">
+            <a:fld id="{5CE29A16-20B6-4905-96EA-3638BD01FA18}" type="slidenum">
               <a:t>10</a:t>
             </a:fld>
           </a:p>
@@ -5878,8 +5877,8 @@
         </p:nvSpPr>
         <p:spPr>
           <a:xfrm>
-            <a:off x="961920" y="-215280"/>
-            <a:ext cx="8637480" cy="901080"/>
+            <a:off x="961920" y="-215640"/>
+            <a:ext cx="8637120" cy="901440"/>
           </a:xfrm>
           <a:prstGeom prst="rect">
             <a:avLst/>
@@ -5915,9 +5914,9 @@
               </a:rPr>
               <a:t>Admin use-case</a:t>
             </a:r>
-            <a:endParaRPr b="0" lang="en-US" sz="3200" strike="noStrike" u="none">
-              <a:solidFill>
-                <a:schemeClr val="dk1"/>
+            <a:endParaRPr b="0" lang="en-IN" sz="3200" strike="noStrike" u="none">
+              <a:solidFill>
+                <a:srgbClr val="000000"/>
               </a:solidFill>
               <a:effectLst/>
               <a:uFillTx/>
@@ -5940,7 +5939,7 @@
         <p:spPr>
           <a:xfrm>
             <a:off x="2057400" y="457200"/>
-            <a:ext cx="5248440" cy="5256000"/>
+            <a:ext cx="5248080" cy="5255640"/>
           </a:xfrm>
           <a:prstGeom prst="rect">
             <a:avLst/>
@@ -5965,7 +5964,7 @@
         <p:txBody>
           <a:bodyPr/>
           <a:p>
-            <a:fld id="{C4D8B646-E0E4-4109-AA94-5FF72E78A5F0}" type="slidenum">
+            <a:fld id="{61FCDEB3-DCC9-44A3-88C9-5D926512F4FA}" type="slidenum">
               <a:t>11</a:t>
             </a:fld>
           </a:p>
@@ -6013,8 +6012,8 @@
         </p:nvSpPr>
         <p:spPr>
           <a:xfrm>
-            <a:off x="720000" y="357840"/>
-            <a:ext cx="8637480" cy="901800"/>
+            <a:off x="720000" y="357480"/>
+            <a:ext cx="8637120" cy="902160"/>
           </a:xfrm>
           <a:prstGeom prst="rect">
             <a:avLst/>
@@ -6050,9 +6049,9 @@
               </a:rPr>
               <a:t>Class Diagram</a:t>
             </a:r>
-            <a:endParaRPr b="0" lang="en-US" sz="3200" strike="noStrike" u="none">
-              <a:solidFill>
-                <a:schemeClr val="dk1"/>
+            <a:endParaRPr b="0" lang="en-IN" sz="3200" strike="noStrike" u="none">
+              <a:solidFill>
+                <a:srgbClr val="000000"/>
               </a:solidFill>
               <a:effectLst/>
               <a:uFillTx/>
@@ -6075,7 +6074,7 @@
         <p:spPr>
           <a:xfrm>
             <a:off x="3200400" y="1143000"/>
-            <a:ext cx="3198240" cy="4158360"/>
+            <a:ext cx="3197880" cy="4158000"/>
           </a:xfrm>
           <a:prstGeom prst="rect">
             <a:avLst/>
@@ -6100,7 +6099,7 @@
         <p:txBody>
           <a:bodyPr/>
           <a:p>
-            <a:fld id="{EC0A0004-9452-4544-B18B-C4401E1DA393}" type="slidenum">
+            <a:fld id="{5D777592-7F4D-45B3-9F8A-D05EF47DD3DB}" type="slidenum">
               <a:t>12</a:t>
             </a:fld>
           </a:p>
@@ -6148,8 +6147,8 @@
         </p:nvSpPr>
         <p:spPr>
           <a:xfrm>
-            <a:off x="685800" y="-230400"/>
-            <a:ext cx="8637480" cy="901800"/>
+            <a:off x="685800" y="-230760"/>
+            <a:ext cx="8637120" cy="902160"/>
           </a:xfrm>
           <a:prstGeom prst="rect">
             <a:avLst/>
@@ -6185,9 +6184,9 @@
               </a:rPr>
               <a:t>Activity Diagram</a:t>
             </a:r>
-            <a:endParaRPr b="0" lang="en-US" sz="3200" strike="noStrike" u="none">
-              <a:solidFill>
-                <a:schemeClr val="dk1"/>
+            <a:endParaRPr b="0" lang="en-IN" sz="3200" strike="noStrike" u="none">
+              <a:solidFill>
+                <a:srgbClr val="000000"/>
               </a:solidFill>
               <a:effectLst/>
               <a:uFillTx/>
@@ -6210,7 +6209,7 @@
         <p:spPr>
           <a:xfrm>
             <a:off x="4343400" y="457200"/>
-            <a:ext cx="2606040" cy="5213160"/>
+            <a:ext cx="2605680" cy="5212800"/>
           </a:xfrm>
           <a:prstGeom prst="rect">
             <a:avLst/>
@@ -6235,7 +6234,7 @@
         <p:txBody>
           <a:bodyPr/>
           <a:p>
-            <a:fld id="{E0EFE9C3-C55F-4280-9069-FA1F174FB74D}" type="slidenum">
+            <a:fld id="{7B392A8A-5708-488E-B018-BF04557EB125}" type="slidenum">
               <a:t>13</a:t>
             </a:fld>
           </a:p>
@@ -6283,8 +6282,8 @@
         </p:nvSpPr>
         <p:spPr>
           <a:xfrm>
-            <a:off x="720000" y="357840"/>
-            <a:ext cx="8637480" cy="901800"/>
+            <a:off x="733680" y="-215640"/>
+            <a:ext cx="8637120" cy="901440"/>
           </a:xfrm>
           <a:prstGeom prst="rect">
             <a:avLst/>
@@ -6309,1120 +6308,6 @@
               </a:tabLst>
             </a:pPr>
             <a:r>
-              <a:rPr b="1" lang="en-US" sz="3200" strike="noStrike" u="none">
-                <a:solidFill>
-                  <a:srgbClr val="000000"/>
-                </a:solidFill>
-                <a:effectLst/>
-                <a:uFillTx/>
-                <a:latin typeface="FreeSans"/>
-                <a:ea typeface="DejaVu Sans"/>
-              </a:rPr>
-              <a:t>Data Dictionary</a:t>
-            </a:r>
-            <a:endParaRPr b="0" lang="en-US" sz="3200" strike="noStrike" u="none">
-              <a:solidFill>
-                <a:schemeClr val="dk1"/>
-              </a:solidFill>
-              <a:effectLst/>
-              <a:uFillTx/>
-              <a:latin typeface="Arial"/>
-            </a:endParaRPr>
-          </a:p>
-        </p:txBody>
-      </p:sp>
-      <p:graphicFrame>
-        <p:nvGraphicFramePr>
-          <p:cNvPr id="82" name="Table 75"/>
-          <p:cNvGraphicFramePr/>
-          <p:nvPr/>
-        </p:nvGraphicFramePr>
-        <p:xfrm>
-          <a:off x="840240" y="1945800"/>
-          <a:ext cx="8195040" cy="2928960"/>
-        </p:xfrm>
-        <a:graphic>
-          <a:graphicData uri="http://schemas.openxmlformats.org/drawingml/2006/table">
-            <a:tbl>
-              <a:tblPr/>
-              <a:tblGrid>
-                <a:gridCol w="4097520"/>
-                <a:gridCol w="4097880"/>
-              </a:tblGrid>
-              <a:tr h="0">
-                <a:tc>
-                  <a:txBody>
-                    <a:bodyPr lIns="36000" rIns="36000" anchor="t">
-                      <a:noAutofit/>
-                    </a:bodyPr>
-                    <a:p>
-                      <a:pPr defTabSz="914400">
-                        <a:lnSpc>
-                          <a:spcPct val="100000"/>
-                        </a:lnSpc>
-                      </a:pPr>
-                      <a:r>
-                        <a:rPr b="0" lang="en-US" sz="1800" strike="noStrike" u="none">
-                          <a:solidFill>
-                            <a:srgbClr val="000000"/>
-                          </a:solidFill>
-                          <a:effectLst/>
-                          <a:uFillTx/>
-                          <a:latin typeface="FreeSans"/>
-                          <a:ea typeface="DejaVu Sans"/>
-                        </a:rPr>
-                        <a:t>userId </a:t>
-                      </a:r>
-                      <a:endParaRPr b="0" lang="en-IN" sz="1800" strike="noStrike" u="none">
-                        <a:solidFill>
-                          <a:srgbClr val="000000"/>
-                        </a:solidFill>
-                        <a:effectLst/>
-                        <a:uFillTx/>
-                        <a:latin typeface="Arial"/>
-                      </a:endParaRPr>
-                    </a:p>
-                  </a:txBody>
-                  <a:tcPr anchor="t" marL="36000" marR="36000" marT="45720" marB="45720">
-                    <a:lnL w="7200">
-                      <a:solidFill>
-                        <a:srgbClr val="000000"/>
-                      </a:solidFill>
-                      <a:prstDash val="solid"/>
-                    </a:lnL>
-                    <a:lnR w="7200">
-                      <a:solidFill>
-                        <a:srgbClr val="000000"/>
-                      </a:solidFill>
-                      <a:prstDash val="solid"/>
-                    </a:lnR>
-                    <a:lnT w="7200">
-                      <a:solidFill>
-                        <a:srgbClr val="000000"/>
-                      </a:solidFill>
-                      <a:prstDash val="solid"/>
-                    </a:lnT>
-                    <a:lnB w="7200">
-                      <a:solidFill>
-                        <a:srgbClr val="000000"/>
-                      </a:solidFill>
-                      <a:prstDash val="solid"/>
-                    </a:lnB>
-                    <a:noFill/>
-                  </a:tcPr>
-                </a:tc>
-                <a:tc>
-                  <a:txBody>
-                    <a:bodyPr lIns="36000" rIns="36000" anchor="t">
-                      <a:noAutofit/>
-                    </a:bodyPr>
-                    <a:p>
-                      <a:pPr defTabSz="914400">
-                        <a:lnSpc>
-                          <a:spcPct val="100000"/>
-                        </a:lnSpc>
-                      </a:pPr>
-                      <a:r>
-                        <a:rPr b="0" lang="en-US" sz="1800" strike="noStrike" u="none">
-                          <a:solidFill>
-                            <a:srgbClr val="000000"/>
-                          </a:solidFill>
-                          <a:effectLst/>
-                          <a:uFillTx/>
-                          <a:latin typeface="FreeSans"/>
-                          <a:ea typeface="DejaVu Sans"/>
-                        </a:rPr>
-                        <a:t>Id of user</a:t>
-                      </a:r>
-                      <a:endParaRPr b="0" lang="en-IN" sz="1800" strike="noStrike" u="none">
-                        <a:solidFill>
-                          <a:srgbClr val="000000"/>
-                        </a:solidFill>
-                        <a:effectLst/>
-                        <a:uFillTx/>
-                        <a:latin typeface="Arial"/>
-                      </a:endParaRPr>
-                    </a:p>
-                  </a:txBody>
-                  <a:tcPr anchor="t" marL="36000" marR="36000" marT="45720" marB="45720">
-                    <a:lnL w="7200">
-                      <a:solidFill>
-                        <a:srgbClr val="000000"/>
-                      </a:solidFill>
-                      <a:prstDash val="solid"/>
-                    </a:lnL>
-                    <a:lnR w="7200">
-                      <a:solidFill>
-                        <a:srgbClr val="000000"/>
-                      </a:solidFill>
-                      <a:prstDash val="solid"/>
-                    </a:lnR>
-                    <a:lnT w="7200">
-                      <a:solidFill>
-                        <a:srgbClr val="000000"/>
-                      </a:solidFill>
-                      <a:prstDash val="solid"/>
-                    </a:lnT>
-                    <a:lnB w="7200">
-                      <a:solidFill>
-                        <a:srgbClr val="000000"/>
-                      </a:solidFill>
-                      <a:prstDash val="solid"/>
-                    </a:lnB>
-                    <a:noFill/>
-                  </a:tcPr>
-                </a:tc>
-              </a:tr>
-              <a:tr h="0">
-                <a:tc>
-                  <a:txBody>
-                    <a:bodyPr lIns="36000" rIns="36000" anchor="t">
-                      <a:noAutofit/>
-                    </a:bodyPr>
-                    <a:p>
-                      <a:pPr defTabSz="914400">
-                        <a:lnSpc>
-                          <a:spcPct val="100000"/>
-                        </a:lnSpc>
-                        <a:tabLst>
-                          <a:tab algn="l" pos="0"/>
-                        </a:tabLst>
-                      </a:pPr>
-                      <a:r>
-                        <a:rPr b="0" lang="en-US" sz="1800" strike="noStrike" u="none">
-                          <a:solidFill>
-                            <a:srgbClr val="000000"/>
-                          </a:solidFill>
-                          <a:effectLst/>
-                          <a:uFillTx/>
-                          <a:latin typeface="FreeSans"/>
-                          <a:ea typeface="DejaVu Sans"/>
-                        </a:rPr>
-                        <a:t>name </a:t>
-                      </a:r>
-                      <a:endParaRPr b="0" lang="en-IN" sz="1800" strike="noStrike" u="none">
-                        <a:solidFill>
-                          <a:srgbClr val="000000"/>
-                        </a:solidFill>
-                        <a:effectLst/>
-                        <a:uFillTx/>
-                        <a:latin typeface="Arial"/>
-                      </a:endParaRPr>
-                    </a:p>
-                  </a:txBody>
-                  <a:tcPr anchor="t" marL="36000" marR="36000" marT="45720" marB="45720">
-                    <a:lnL w="7200">
-                      <a:solidFill>
-                        <a:srgbClr val="000000"/>
-                      </a:solidFill>
-                      <a:prstDash val="solid"/>
-                    </a:lnL>
-                    <a:lnR w="7200">
-                      <a:solidFill>
-                        <a:srgbClr val="000000"/>
-                      </a:solidFill>
-                      <a:prstDash val="solid"/>
-                    </a:lnR>
-                    <a:lnT w="7200">
-                      <a:solidFill>
-                        <a:srgbClr val="000000"/>
-                      </a:solidFill>
-                      <a:prstDash val="solid"/>
-                    </a:lnT>
-                    <a:lnB w="7200">
-                      <a:solidFill>
-                        <a:srgbClr val="000000"/>
-                      </a:solidFill>
-                      <a:prstDash val="solid"/>
-                    </a:lnB>
-                    <a:noFill/>
-                  </a:tcPr>
-                </a:tc>
-                <a:tc>
-                  <a:txBody>
-                    <a:bodyPr lIns="36000" rIns="36000" anchor="t">
-                      <a:noAutofit/>
-                    </a:bodyPr>
-                    <a:p>
-                      <a:pPr defTabSz="914400">
-                        <a:lnSpc>
-                          <a:spcPct val="100000"/>
-                        </a:lnSpc>
-                        <a:tabLst>
-                          <a:tab algn="l" pos="0"/>
-                        </a:tabLst>
-                      </a:pPr>
-                      <a:r>
-                        <a:rPr b="0" lang="en-US" sz="1800" strike="noStrike" u="none">
-                          <a:solidFill>
-                            <a:srgbClr val="000000"/>
-                          </a:solidFill>
-                          <a:effectLst/>
-                          <a:uFillTx/>
-                          <a:latin typeface="FreeSans"/>
-                          <a:ea typeface="DejaVu Sans"/>
-                        </a:rPr>
-                        <a:t>Name of the user</a:t>
-                      </a:r>
-                      <a:endParaRPr b="0" lang="en-IN" sz="1800" strike="noStrike" u="none">
-                        <a:solidFill>
-                          <a:srgbClr val="000000"/>
-                        </a:solidFill>
-                        <a:effectLst/>
-                        <a:uFillTx/>
-                        <a:latin typeface="Arial"/>
-                      </a:endParaRPr>
-                    </a:p>
-                  </a:txBody>
-                  <a:tcPr anchor="t" marL="36000" marR="36000" marT="45720" marB="45720">
-                    <a:lnL w="7200">
-                      <a:solidFill>
-                        <a:srgbClr val="000000"/>
-                      </a:solidFill>
-                      <a:prstDash val="solid"/>
-                    </a:lnL>
-                    <a:lnR w="7200">
-                      <a:solidFill>
-                        <a:srgbClr val="000000"/>
-                      </a:solidFill>
-                      <a:prstDash val="solid"/>
-                    </a:lnR>
-                    <a:lnT w="7200">
-                      <a:solidFill>
-                        <a:srgbClr val="000000"/>
-                      </a:solidFill>
-                      <a:prstDash val="solid"/>
-                    </a:lnT>
-                    <a:lnB w="7200">
-                      <a:solidFill>
-                        <a:srgbClr val="000000"/>
-                      </a:solidFill>
-                      <a:prstDash val="solid"/>
-                    </a:lnB>
-                    <a:noFill/>
-                  </a:tcPr>
-                </a:tc>
-              </a:tr>
-              <a:tr h="366120">
-                <a:tc>
-                  <a:txBody>
-                    <a:bodyPr lIns="36000" rIns="36000" anchor="t">
-                      <a:noAutofit/>
-                    </a:bodyPr>
-                    <a:p>
-                      <a:pPr defTabSz="914400">
-                        <a:lnSpc>
-                          <a:spcPct val="100000"/>
-                        </a:lnSpc>
-                        <a:tabLst>
-                          <a:tab algn="l" pos="0"/>
-                        </a:tabLst>
-                      </a:pPr>
-                      <a:r>
-                        <a:rPr b="0" lang="en-US" sz="1800" strike="noStrike" u="none">
-                          <a:solidFill>
-                            <a:srgbClr val="000000"/>
-                          </a:solidFill>
-                          <a:effectLst/>
-                          <a:uFillTx/>
-                          <a:latin typeface="FreeSans"/>
-                          <a:ea typeface="DejaVu Sans"/>
-                        </a:rPr>
-                        <a:t>email </a:t>
-                      </a:r>
-                      <a:endParaRPr b="0" lang="en-IN" sz="1800" strike="noStrike" u="none">
-                        <a:solidFill>
-                          <a:srgbClr val="000000"/>
-                        </a:solidFill>
-                        <a:effectLst/>
-                        <a:uFillTx/>
-                        <a:latin typeface="Arial"/>
-                      </a:endParaRPr>
-                    </a:p>
-                  </a:txBody>
-                  <a:tcPr anchor="t" marL="36000" marR="36000" marT="45720" marB="45720">
-                    <a:lnL w="7200">
-                      <a:solidFill>
-                        <a:srgbClr val="000000"/>
-                      </a:solidFill>
-                      <a:prstDash val="solid"/>
-                    </a:lnL>
-                    <a:lnR w="7200">
-                      <a:solidFill>
-                        <a:srgbClr val="000000"/>
-                      </a:solidFill>
-                      <a:prstDash val="solid"/>
-                    </a:lnR>
-                    <a:lnT w="7200">
-                      <a:solidFill>
-                        <a:srgbClr val="000000"/>
-                      </a:solidFill>
-                      <a:prstDash val="solid"/>
-                    </a:lnT>
-                    <a:lnB w="7200">
-                      <a:solidFill>
-                        <a:srgbClr val="000000"/>
-                      </a:solidFill>
-                      <a:prstDash val="solid"/>
-                    </a:lnB>
-                    <a:noFill/>
-                  </a:tcPr>
-                </a:tc>
-                <a:tc>
-                  <a:txBody>
-                    <a:bodyPr lIns="36000" rIns="36000" anchor="t">
-                      <a:noAutofit/>
-                    </a:bodyPr>
-                    <a:p>
-                      <a:pPr defTabSz="914400">
-                        <a:lnSpc>
-                          <a:spcPct val="100000"/>
-                        </a:lnSpc>
-                        <a:tabLst>
-                          <a:tab algn="l" pos="0"/>
-                        </a:tabLst>
-                      </a:pPr>
-                      <a:r>
-                        <a:rPr b="0" lang="en-US" sz="1800" strike="noStrike" u="none">
-                          <a:solidFill>
-                            <a:srgbClr val="000000"/>
-                          </a:solidFill>
-                          <a:effectLst/>
-                          <a:uFillTx/>
-                          <a:latin typeface="FreeSans"/>
-                          <a:ea typeface="DejaVu Sans"/>
-                        </a:rPr>
-                        <a:t>Email of the user</a:t>
-                      </a:r>
-                      <a:endParaRPr b="0" lang="en-IN" sz="1800" strike="noStrike" u="none">
-                        <a:solidFill>
-                          <a:srgbClr val="000000"/>
-                        </a:solidFill>
-                        <a:effectLst/>
-                        <a:uFillTx/>
-                        <a:latin typeface="Arial"/>
-                      </a:endParaRPr>
-                    </a:p>
-                  </a:txBody>
-                  <a:tcPr anchor="t" marL="36000" marR="36000" marT="45720" marB="45720">
-                    <a:lnL w="7200">
-                      <a:solidFill>
-                        <a:srgbClr val="000000"/>
-                      </a:solidFill>
-                      <a:prstDash val="solid"/>
-                    </a:lnL>
-                    <a:lnR w="7200">
-                      <a:solidFill>
-                        <a:srgbClr val="000000"/>
-                      </a:solidFill>
-                      <a:prstDash val="solid"/>
-                    </a:lnR>
-                    <a:lnT w="7200">
-                      <a:solidFill>
-                        <a:srgbClr val="000000"/>
-                      </a:solidFill>
-                      <a:prstDash val="solid"/>
-                    </a:lnT>
-                    <a:lnB w="7200">
-                      <a:solidFill>
-                        <a:srgbClr val="000000"/>
-                      </a:solidFill>
-                      <a:prstDash val="solid"/>
-                    </a:lnB>
-                    <a:noFill/>
-                  </a:tcPr>
-                </a:tc>
-              </a:tr>
-              <a:tr h="366120">
-                <a:tc>
-                  <a:txBody>
-                    <a:bodyPr lIns="36000" rIns="36000" anchor="t">
-                      <a:noAutofit/>
-                    </a:bodyPr>
-                    <a:p>
-                      <a:pPr defTabSz="914400">
-                        <a:lnSpc>
-                          <a:spcPct val="100000"/>
-                        </a:lnSpc>
-                        <a:tabLst>
-                          <a:tab algn="l" pos="0"/>
-                        </a:tabLst>
-                      </a:pPr>
-                      <a:r>
-                        <a:rPr b="0" lang="en-US" sz="1800" strike="noStrike" u="none">
-                          <a:solidFill>
-                            <a:srgbClr val="000000"/>
-                          </a:solidFill>
-                          <a:effectLst/>
-                          <a:uFillTx/>
-                          <a:latin typeface="FreeSans"/>
-                          <a:ea typeface="DejaVu Sans"/>
-                        </a:rPr>
-                        <a:t>phone </a:t>
-                      </a:r>
-                      <a:endParaRPr b="0" lang="en-IN" sz="1800" strike="noStrike" u="none">
-                        <a:solidFill>
-                          <a:srgbClr val="000000"/>
-                        </a:solidFill>
-                        <a:effectLst/>
-                        <a:uFillTx/>
-                        <a:latin typeface="Arial"/>
-                      </a:endParaRPr>
-                    </a:p>
-                  </a:txBody>
-                  <a:tcPr anchor="t" marL="36000" marR="36000" marT="45720" marB="45720">
-                    <a:lnL w="7200">
-                      <a:solidFill>
-                        <a:srgbClr val="000000"/>
-                      </a:solidFill>
-                      <a:prstDash val="solid"/>
-                    </a:lnL>
-                    <a:lnR w="7200">
-                      <a:solidFill>
-                        <a:srgbClr val="000000"/>
-                      </a:solidFill>
-                      <a:prstDash val="solid"/>
-                    </a:lnR>
-                    <a:lnT w="7200">
-                      <a:solidFill>
-                        <a:srgbClr val="000000"/>
-                      </a:solidFill>
-                      <a:prstDash val="solid"/>
-                    </a:lnT>
-                    <a:lnB w="7200">
-                      <a:solidFill>
-                        <a:srgbClr val="000000"/>
-                      </a:solidFill>
-                      <a:prstDash val="solid"/>
-                    </a:lnB>
-                    <a:noFill/>
-                  </a:tcPr>
-                </a:tc>
-                <a:tc>
-                  <a:txBody>
-                    <a:bodyPr lIns="36000" rIns="36000" anchor="t">
-                      <a:noAutofit/>
-                    </a:bodyPr>
-                    <a:p>
-                      <a:pPr defTabSz="914400">
-                        <a:lnSpc>
-                          <a:spcPct val="100000"/>
-                        </a:lnSpc>
-                        <a:tabLst>
-                          <a:tab algn="l" pos="0"/>
-                        </a:tabLst>
-                      </a:pPr>
-                      <a:r>
-                        <a:rPr b="0" lang="en-US" sz="1800" strike="noStrike" u="none">
-                          <a:solidFill>
-                            <a:srgbClr val="000000"/>
-                          </a:solidFill>
-                          <a:effectLst/>
-                          <a:uFillTx/>
-                          <a:latin typeface="FreeSans"/>
-                          <a:ea typeface="DejaVu Sans"/>
-                        </a:rPr>
-                        <a:t>Phone number of the user</a:t>
-                      </a:r>
-                      <a:endParaRPr b="0" lang="en-IN" sz="1800" strike="noStrike" u="none">
-                        <a:solidFill>
-                          <a:srgbClr val="000000"/>
-                        </a:solidFill>
-                        <a:effectLst/>
-                        <a:uFillTx/>
-                        <a:latin typeface="Arial"/>
-                      </a:endParaRPr>
-                    </a:p>
-                  </a:txBody>
-                  <a:tcPr anchor="t" marL="36000" marR="36000" marT="45720" marB="45720">
-                    <a:lnL w="7200">
-                      <a:solidFill>
-                        <a:srgbClr val="000000"/>
-                      </a:solidFill>
-                      <a:prstDash val="solid"/>
-                    </a:lnL>
-                    <a:lnR w="7200">
-                      <a:solidFill>
-                        <a:srgbClr val="000000"/>
-                      </a:solidFill>
-                      <a:prstDash val="solid"/>
-                    </a:lnR>
-                    <a:lnT w="7200">
-                      <a:solidFill>
-                        <a:srgbClr val="000000"/>
-                      </a:solidFill>
-                      <a:prstDash val="solid"/>
-                    </a:lnT>
-                    <a:lnB w="7200">
-                      <a:solidFill>
-                        <a:srgbClr val="000000"/>
-                      </a:solidFill>
-                      <a:prstDash val="solid"/>
-                    </a:lnB>
-                    <a:noFill/>
-                  </a:tcPr>
-                </a:tc>
-              </a:tr>
-              <a:tr h="366120">
-                <a:tc>
-                  <a:txBody>
-                    <a:bodyPr lIns="36000" rIns="36000" anchor="t">
-                      <a:noAutofit/>
-                    </a:bodyPr>
-                    <a:p>
-                      <a:pPr defTabSz="914400">
-                        <a:lnSpc>
-                          <a:spcPct val="100000"/>
-                        </a:lnSpc>
-                        <a:tabLst>
-                          <a:tab algn="l" pos="0"/>
-                        </a:tabLst>
-                      </a:pPr>
-                      <a:r>
-                        <a:rPr b="0" lang="en-US" sz="1800" strike="noStrike" u="none">
-                          <a:solidFill>
-                            <a:srgbClr val="000000"/>
-                          </a:solidFill>
-                          <a:effectLst/>
-                          <a:uFillTx/>
-                          <a:latin typeface="FreeSans"/>
-                          <a:ea typeface="DejaVu Sans"/>
-                        </a:rPr>
-                        <a:t>role </a:t>
-                      </a:r>
-                      <a:endParaRPr b="0" lang="en-IN" sz="1800" strike="noStrike" u="none">
-                        <a:solidFill>
-                          <a:srgbClr val="000000"/>
-                        </a:solidFill>
-                        <a:effectLst/>
-                        <a:uFillTx/>
-                        <a:latin typeface="Arial"/>
-                      </a:endParaRPr>
-                    </a:p>
-                  </a:txBody>
-                  <a:tcPr anchor="t" marL="36000" marR="36000" marT="45720" marB="45720">
-                    <a:lnL w="7200">
-                      <a:solidFill>
-                        <a:srgbClr val="000000"/>
-                      </a:solidFill>
-                      <a:prstDash val="solid"/>
-                    </a:lnL>
-                    <a:lnR w="7200">
-                      <a:solidFill>
-                        <a:srgbClr val="000000"/>
-                      </a:solidFill>
-                      <a:prstDash val="solid"/>
-                    </a:lnR>
-                    <a:lnT w="7200">
-                      <a:solidFill>
-                        <a:srgbClr val="000000"/>
-                      </a:solidFill>
-                      <a:prstDash val="solid"/>
-                    </a:lnT>
-                    <a:lnB w="7200">
-                      <a:solidFill>
-                        <a:srgbClr val="000000"/>
-                      </a:solidFill>
-                      <a:prstDash val="solid"/>
-                    </a:lnB>
-                    <a:noFill/>
-                  </a:tcPr>
-                </a:tc>
-                <a:tc>
-                  <a:txBody>
-                    <a:bodyPr lIns="36000" rIns="36000" anchor="t">
-                      <a:noAutofit/>
-                    </a:bodyPr>
-                    <a:p>
-                      <a:pPr defTabSz="914400">
-                        <a:lnSpc>
-                          <a:spcPct val="100000"/>
-                        </a:lnSpc>
-                        <a:tabLst>
-                          <a:tab algn="l" pos="0"/>
-                        </a:tabLst>
-                      </a:pPr>
-                      <a:r>
-                        <a:rPr b="0" lang="en-US" sz="1800" strike="noStrike" u="none">
-                          <a:solidFill>
-                            <a:srgbClr val="000000"/>
-                          </a:solidFill>
-                          <a:effectLst/>
-                          <a:uFillTx/>
-                          <a:latin typeface="FreeSans"/>
-                          <a:ea typeface="DejaVu Sans"/>
-                        </a:rPr>
-                        <a:t>Role of the user</a:t>
-                      </a:r>
-                      <a:endParaRPr b="0" lang="en-IN" sz="1800" strike="noStrike" u="none">
-                        <a:solidFill>
-                          <a:srgbClr val="000000"/>
-                        </a:solidFill>
-                        <a:effectLst/>
-                        <a:uFillTx/>
-                        <a:latin typeface="Arial"/>
-                      </a:endParaRPr>
-                    </a:p>
-                  </a:txBody>
-                  <a:tcPr anchor="t" marL="36000" marR="36000" marT="45720" marB="45720">
-                    <a:lnL w="7200">
-                      <a:solidFill>
-                        <a:srgbClr val="000000"/>
-                      </a:solidFill>
-                      <a:prstDash val="solid"/>
-                    </a:lnL>
-                    <a:lnR w="7200">
-                      <a:solidFill>
-                        <a:srgbClr val="000000"/>
-                      </a:solidFill>
-                      <a:prstDash val="solid"/>
-                    </a:lnR>
-                    <a:lnT w="7200">
-                      <a:solidFill>
-                        <a:srgbClr val="000000"/>
-                      </a:solidFill>
-                      <a:prstDash val="solid"/>
-                    </a:lnT>
-                    <a:lnB w="7200">
-                      <a:solidFill>
-                        <a:srgbClr val="000000"/>
-                      </a:solidFill>
-                      <a:prstDash val="solid"/>
-                    </a:lnB>
-                    <a:noFill/>
-                  </a:tcPr>
-                </a:tc>
-              </a:tr>
-              <a:tr h="366120">
-                <a:tc>
-                  <a:txBody>
-                    <a:bodyPr lIns="36000" rIns="36000" anchor="t">
-                      <a:noAutofit/>
-                    </a:bodyPr>
-                    <a:p>
-                      <a:pPr defTabSz="914400">
-                        <a:lnSpc>
-                          <a:spcPct val="100000"/>
-                        </a:lnSpc>
-                        <a:tabLst>
-                          <a:tab algn="l" pos="0"/>
-                        </a:tabLst>
-                      </a:pPr>
-                      <a:r>
-                        <a:rPr b="0" lang="en-US" sz="1800" strike="noStrike" u="none">
-                          <a:solidFill>
-                            <a:srgbClr val="000000"/>
-                          </a:solidFill>
-                          <a:effectLst/>
-                          <a:uFillTx/>
-                          <a:latin typeface="FreeSans"/>
-                          <a:ea typeface="DejaVu Sans"/>
-                        </a:rPr>
-                        <a:t>createdAt</a:t>
-                      </a:r>
-                      <a:endParaRPr b="0" lang="en-IN" sz="1800" strike="noStrike" u="none">
-                        <a:solidFill>
-                          <a:srgbClr val="000000"/>
-                        </a:solidFill>
-                        <a:effectLst/>
-                        <a:uFillTx/>
-                        <a:latin typeface="Arial"/>
-                      </a:endParaRPr>
-                    </a:p>
-                  </a:txBody>
-                  <a:tcPr anchor="t" marL="36000" marR="36000" marT="45720" marB="45720">
-                    <a:lnL w="7200">
-                      <a:solidFill>
-                        <a:srgbClr val="000000"/>
-                      </a:solidFill>
-                      <a:prstDash val="solid"/>
-                    </a:lnL>
-                    <a:lnR w="7200">
-                      <a:solidFill>
-                        <a:srgbClr val="000000"/>
-                      </a:solidFill>
-                      <a:prstDash val="solid"/>
-                    </a:lnR>
-                    <a:lnT w="7200">
-                      <a:solidFill>
-                        <a:srgbClr val="000000"/>
-                      </a:solidFill>
-                      <a:prstDash val="solid"/>
-                    </a:lnT>
-                    <a:lnB w="7200">
-                      <a:solidFill>
-                        <a:srgbClr val="000000"/>
-                      </a:solidFill>
-                      <a:prstDash val="solid"/>
-                    </a:lnB>
-                    <a:noFill/>
-                  </a:tcPr>
-                </a:tc>
-                <a:tc>
-                  <a:txBody>
-                    <a:bodyPr lIns="36000" rIns="36000" anchor="t">
-                      <a:noAutofit/>
-                    </a:bodyPr>
-                    <a:p>
-                      <a:pPr defTabSz="914400">
-                        <a:lnSpc>
-                          <a:spcPct val="100000"/>
-                        </a:lnSpc>
-                        <a:tabLst>
-                          <a:tab algn="l" pos="0"/>
-                        </a:tabLst>
-                      </a:pPr>
-                      <a:r>
-                        <a:rPr b="0" lang="en-US" sz="1800" strike="noStrike" u="none">
-                          <a:solidFill>
-                            <a:srgbClr val="000000"/>
-                          </a:solidFill>
-                          <a:effectLst/>
-                          <a:uFillTx/>
-                          <a:latin typeface="FreeSans"/>
-                          <a:ea typeface="DejaVu Sans"/>
-                        </a:rPr>
-                        <a:t>Timestamp of creation time</a:t>
-                      </a:r>
-                      <a:endParaRPr b="0" lang="en-IN" sz="1800" strike="noStrike" u="none">
-                        <a:solidFill>
-                          <a:srgbClr val="000000"/>
-                        </a:solidFill>
-                        <a:effectLst/>
-                        <a:uFillTx/>
-                        <a:latin typeface="Arial"/>
-                      </a:endParaRPr>
-                    </a:p>
-                  </a:txBody>
-                  <a:tcPr anchor="t" marL="36000" marR="36000" marT="45720" marB="45720">
-                    <a:lnL w="7200">
-                      <a:solidFill>
-                        <a:srgbClr val="000000"/>
-                      </a:solidFill>
-                      <a:prstDash val="solid"/>
-                    </a:lnL>
-                    <a:lnR w="7200">
-                      <a:solidFill>
-                        <a:srgbClr val="000000"/>
-                      </a:solidFill>
-                      <a:prstDash val="solid"/>
-                    </a:lnR>
-                    <a:lnT w="7200">
-                      <a:solidFill>
-                        <a:srgbClr val="000000"/>
-                      </a:solidFill>
-                      <a:prstDash val="solid"/>
-                    </a:lnT>
-                    <a:lnB w="7200">
-                      <a:solidFill>
-                        <a:srgbClr val="000000"/>
-                      </a:solidFill>
-                      <a:prstDash val="solid"/>
-                    </a:lnB>
-                    <a:noFill/>
-                  </a:tcPr>
-                </a:tc>
-              </a:tr>
-              <a:tr h="366120">
-                <a:tc>
-                  <a:txBody>
-                    <a:bodyPr lIns="36000" rIns="36000" anchor="t">
-                      <a:noAutofit/>
-                    </a:bodyPr>
-                    <a:p>
-                      <a:pPr defTabSz="914400">
-                        <a:lnSpc>
-                          <a:spcPct val="100000"/>
-                        </a:lnSpc>
-                        <a:tabLst>
-                          <a:tab algn="l" pos="0"/>
-                        </a:tabLst>
-                      </a:pPr>
-                      <a:r>
-                        <a:rPr b="0" lang="en-US" sz="1800" strike="noStrike" u="none">
-                          <a:solidFill>
-                            <a:srgbClr val="000000"/>
-                          </a:solidFill>
-                          <a:effectLst/>
-                          <a:uFillTx/>
-                          <a:latin typeface="FreeSans"/>
-                          <a:ea typeface="DejaVu Sans"/>
-                        </a:rPr>
-                        <a:t>profileImage</a:t>
-                      </a:r>
-                      <a:endParaRPr b="0" lang="en-IN" sz="1800" strike="noStrike" u="none">
-                        <a:solidFill>
-                          <a:srgbClr val="000000"/>
-                        </a:solidFill>
-                        <a:effectLst/>
-                        <a:uFillTx/>
-                        <a:latin typeface="Arial"/>
-                      </a:endParaRPr>
-                    </a:p>
-                  </a:txBody>
-                  <a:tcPr anchor="t" marL="36000" marR="36000" marT="45720" marB="45720">
-                    <a:lnL w="7200">
-                      <a:solidFill>
-                        <a:srgbClr val="000000"/>
-                      </a:solidFill>
-                      <a:prstDash val="solid"/>
-                    </a:lnL>
-                    <a:lnR w="7200">
-                      <a:solidFill>
-                        <a:srgbClr val="000000"/>
-                      </a:solidFill>
-                      <a:prstDash val="solid"/>
-                    </a:lnR>
-                    <a:lnT w="7200">
-                      <a:solidFill>
-                        <a:srgbClr val="000000"/>
-                      </a:solidFill>
-                      <a:prstDash val="solid"/>
-                    </a:lnT>
-                    <a:lnB w="7200">
-                      <a:solidFill>
-                        <a:srgbClr val="000000"/>
-                      </a:solidFill>
-                      <a:prstDash val="solid"/>
-                    </a:lnB>
-                    <a:noFill/>
-                  </a:tcPr>
-                </a:tc>
-                <a:tc>
-                  <a:txBody>
-                    <a:bodyPr lIns="36000" rIns="36000" anchor="t">
-                      <a:noAutofit/>
-                    </a:bodyPr>
-                    <a:p>
-                      <a:pPr defTabSz="914400">
-                        <a:lnSpc>
-                          <a:spcPct val="100000"/>
-                        </a:lnSpc>
-                        <a:tabLst>
-                          <a:tab algn="l" pos="0"/>
-                        </a:tabLst>
-                      </a:pPr>
-                      <a:r>
-                        <a:rPr b="0" lang="en-US" sz="1800" strike="noStrike" u="none">
-                          <a:solidFill>
-                            <a:srgbClr val="000000"/>
-                          </a:solidFill>
-                          <a:effectLst/>
-                          <a:uFillTx/>
-                          <a:latin typeface="FreeSans"/>
-                          <a:ea typeface="DejaVu Sans"/>
-                        </a:rPr>
-                        <a:t>Profile image of user</a:t>
-                      </a:r>
-                      <a:endParaRPr b="0" lang="en-IN" sz="1800" strike="noStrike" u="none">
-                        <a:solidFill>
-                          <a:srgbClr val="000000"/>
-                        </a:solidFill>
-                        <a:effectLst/>
-                        <a:uFillTx/>
-                        <a:latin typeface="Arial"/>
-                      </a:endParaRPr>
-                    </a:p>
-                  </a:txBody>
-                  <a:tcPr anchor="t" marL="36000" marR="36000" marT="45720" marB="45720">
-                    <a:lnL w="7200">
-                      <a:solidFill>
-                        <a:srgbClr val="000000"/>
-                      </a:solidFill>
-                      <a:prstDash val="solid"/>
-                    </a:lnL>
-                    <a:lnR w="7200">
-                      <a:solidFill>
-                        <a:srgbClr val="000000"/>
-                      </a:solidFill>
-                      <a:prstDash val="solid"/>
-                    </a:lnR>
-                    <a:lnT w="7200">
-                      <a:solidFill>
-                        <a:srgbClr val="000000"/>
-                      </a:solidFill>
-                      <a:prstDash val="solid"/>
-                    </a:lnT>
-                    <a:lnB w="7200">
-                      <a:solidFill>
-                        <a:srgbClr val="000000"/>
-                      </a:solidFill>
-                      <a:prstDash val="solid"/>
-                    </a:lnB>
-                    <a:noFill/>
-                  </a:tcPr>
-                </a:tc>
-              </a:tr>
-              <a:tr h="366120">
-                <a:tc>
-                  <a:txBody>
-                    <a:bodyPr lIns="36000" rIns="36000" anchor="t">
-                      <a:noAutofit/>
-                    </a:bodyPr>
-                    <a:p>
-                      <a:pPr defTabSz="914400">
-                        <a:lnSpc>
-                          <a:spcPct val="100000"/>
-                        </a:lnSpc>
-                        <a:tabLst>
-                          <a:tab algn="l" pos="0"/>
-                        </a:tabLst>
-                      </a:pPr>
-                      <a:r>
-                        <a:rPr b="0" lang="en-US" sz="1800" strike="noStrike" u="none">
-                          <a:solidFill>
-                            <a:srgbClr val="000000"/>
-                          </a:solidFill>
-                          <a:effectLst/>
-                          <a:uFillTx/>
-                          <a:latin typeface="FreeSans"/>
-                          <a:ea typeface="DejaVu Sans"/>
-                        </a:rPr>
-                        <a:t>verified</a:t>
-                      </a:r>
-                      <a:endParaRPr b="0" lang="en-IN" sz="1800" strike="noStrike" u="none">
-                        <a:solidFill>
-                          <a:srgbClr val="000000"/>
-                        </a:solidFill>
-                        <a:effectLst/>
-                        <a:uFillTx/>
-                        <a:latin typeface="Arial"/>
-                      </a:endParaRPr>
-                    </a:p>
-                  </a:txBody>
-                  <a:tcPr anchor="t" marL="36000" marR="36000" marT="45720" marB="45720">
-                    <a:lnL w="7200">
-                      <a:solidFill>
-                        <a:srgbClr val="000000"/>
-                      </a:solidFill>
-                      <a:prstDash val="solid"/>
-                    </a:lnL>
-                    <a:lnR w="7200">
-                      <a:solidFill>
-                        <a:srgbClr val="000000"/>
-                      </a:solidFill>
-                      <a:prstDash val="solid"/>
-                    </a:lnR>
-                    <a:lnT w="7200">
-                      <a:solidFill>
-                        <a:srgbClr val="000000"/>
-                      </a:solidFill>
-                      <a:prstDash val="solid"/>
-                    </a:lnT>
-                    <a:lnB w="7200">
-                      <a:solidFill>
-                        <a:srgbClr val="000000"/>
-                      </a:solidFill>
-                      <a:prstDash val="solid"/>
-                    </a:lnB>
-                    <a:noFill/>
-                  </a:tcPr>
-                </a:tc>
-                <a:tc>
-                  <a:txBody>
-                    <a:bodyPr lIns="36000" rIns="36000" anchor="t">
-                      <a:noAutofit/>
-                    </a:bodyPr>
-                    <a:p>
-                      <a:pPr defTabSz="914400">
-                        <a:lnSpc>
-                          <a:spcPct val="100000"/>
-                        </a:lnSpc>
-                        <a:tabLst>
-                          <a:tab algn="l" pos="0"/>
-                        </a:tabLst>
-                      </a:pPr>
-                      <a:r>
-                        <a:rPr b="0" lang="en-US" sz="1800" strike="noStrike" u="none">
-                          <a:solidFill>
-                            <a:srgbClr val="000000"/>
-                          </a:solidFill>
-                          <a:effectLst/>
-                          <a:uFillTx/>
-                          <a:latin typeface="FreeSans"/>
-                          <a:ea typeface="DejaVu Sans"/>
-                        </a:rPr>
-                        <a:t>The user has verified his email or not</a:t>
-                      </a:r>
-                      <a:endParaRPr b="0" lang="en-IN" sz="1800" strike="noStrike" u="none">
-                        <a:solidFill>
-                          <a:srgbClr val="000000"/>
-                        </a:solidFill>
-                        <a:effectLst/>
-                        <a:uFillTx/>
-                        <a:latin typeface="Arial"/>
-                      </a:endParaRPr>
-                    </a:p>
-                  </a:txBody>
-                  <a:tcPr anchor="t" marL="36000" marR="36000" marT="45720" marB="45720">
-                    <a:lnL w="7200">
-                      <a:solidFill>
-                        <a:srgbClr val="000000"/>
-                      </a:solidFill>
-                      <a:prstDash val="solid"/>
-                    </a:lnL>
-                    <a:lnR w="7200">
-                      <a:solidFill>
-                        <a:srgbClr val="000000"/>
-                      </a:solidFill>
-                      <a:prstDash val="solid"/>
-                    </a:lnR>
-                    <a:lnT w="7200">
-                      <a:solidFill>
-                        <a:srgbClr val="000000"/>
-                      </a:solidFill>
-                      <a:prstDash val="solid"/>
-                    </a:lnT>
-                    <a:lnB w="7200">
-                      <a:solidFill>
-                        <a:srgbClr val="000000"/>
-                      </a:solidFill>
-                      <a:prstDash val="solid"/>
-                    </a:lnB>
-                    <a:noFill/>
-                  </a:tcPr>
-                </a:tc>
-              </a:tr>
-            </a:tbl>
-          </a:graphicData>
-        </a:graphic>
-      </p:graphicFrame>
-      <p:sp>
-        <p:nvSpPr>
-          <p:cNvPr id="83" name="Rectangle 76"/>
-          <p:cNvSpPr/>
-          <p:nvPr/>
-        </p:nvSpPr>
-        <p:spPr>
-          <a:xfrm>
-            <a:off x="2514600" y="1259640"/>
-            <a:ext cx="5027400" cy="455400"/>
-          </a:xfrm>
-          <a:prstGeom prst="rect">
-            <a:avLst/>
-          </a:prstGeom>
-          <a:noFill/>
-          <a:ln w="0">
-            <a:noFill/>
-          </a:ln>
-        </p:spPr>
-        <p:style>
-          <a:lnRef idx="0"/>
-          <a:fillRef idx="0"/>
-          <a:effectRef idx="0"/>
-          <a:fontRef idx="minor"/>
-        </p:style>
-        <p:txBody>
-          <a:bodyPr lIns="90000" rIns="90000" tIns="45000" bIns="45000" anchor="t" anchorCtr="1">
-            <a:spAutoFit/>
-          </a:bodyPr>
-          <a:p>
-            <a:pPr algn="ctr" defTabSz="914400">
-              <a:lnSpc>
-                <a:spcPct val="100000"/>
-              </a:lnSpc>
-            </a:pPr>
-            <a:r>
               <a:rPr b="1" lang="en-US" sz="2400" strike="noStrike" u="none">
                 <a:solidFill>
                   <a:srgbClr val="000000"/>
@@ -7432,121 +6317,11 @@
                 <a:latin typeface="FreeSans"/>
                 <a:ea typeface="DejaVu Sans"/>
               </a:rPr>
-              <a:t>users collection</a:t>
+              <a:t>vehicle collection</a:t>
             </a:r>
             <a:endParaRPr b="0" lang="en-IN" sz="2400" strike="noStrike" u="none">
               <a:solidFill>
                 <a:srgbClr val="000000"/>
-              </a:solidFill>
-              <a:effectLst/>
-              <a:uFillTx/>
-              <a:latin typeface="Arial"/>
-            </a:endParaRPr>
-          </a:p>
-        </p:txBody>
-      </p:sp>
-      <p:sp>
-        <p:nvSpPr>
-          <p:cNvPr id="3" name="PlaceHolder 2"/>
-          <p:cNvSpPr>
-            <a:spLocks noGrp="1"/>
-          </p:cNvSpPr>
-          <p:nvPr>
-            <p:ph type="sldNum" idx="3"/>
-          </p:nvPr>
-        </p:nvSpPr>
-        <p:spPr/>
-        <p:txBody>
-          <a:bodyPr/>
-          <a:p>
-            <a:fld id="{733A37BB-BDA9-42BA-990F-D02327960211}" type="slidenum">
-              <a:t>14</a:t>
-            </a:fld>
-          </a:p>
-        </p:txBody>
-      </p:sp>
-    </p:spTree>
-  </p:cSld>
-  <mc:AlternateContent>
-    <mc:Choice Requires="p14">
-      <p:transition spd="slow" p14:dur="2000"/>
-    </mc:Choice>
-    <mc:Fallback>
-      <p:transition spd="slow"/>
-    </mc:Fallback>
-  </mc:AlternateContent>
-</p:sld>
-</file>
-
-<file path=ppt/slides/slide15.xml><?xml version="1.0" encoding="utf-8"?>
-<p:sld xmlns:a="http://schemas.openxmlformats.org/drawingml/2006/main" xmlns:p="http://schemas.openxmlformats.org/presentationml/2006/main" xmlns:r="http://schemas.openxmlformats.org/officeDocument/2006/relationships" xmlns:p14="http://schemas.microsoft.com/office/powerpoint/2010/main" xmlns:p15="http://schemas.microsoft.com/office/powerpoint/2012/main" xmlns:mc="http://schemas.openxmlformats.org/markup-compatibility/2006">
-  <p:cSld>
-    <p:spTree>
-      <p:nvGrpSpPr>
-        <p:cNvPr id="1" name=""/>
-        <p:cNvGrpSpPr/>
-        <p:nvPr/>
-      </p:nvGrpSpPr>
-      <p:grpSpPr>
-        <a:xfrm>
-          <a:off x="0" y="0"/>
-          <a:ext cx="0" cy="0"/>
-          <a:chOff x="0" y="0"/>
-          <a:chExt cx="0" cy="0"/>
-        </a:xfrm>
-      </p:grpSpPr>
-      <p:sp>
-        <p:nvSpPr>
-          <p:cNvPr id="84" name="PlaceHolder 1"/>
-          <p:cNvSpPr>
-            <a:spLocks noGrp="1"/>
-          </p:cNvSpPr>
-          <p:nvPr>
-            <p:ph type="title"/>
-          </p:nvPr>
-        </p:nvSpPr>
-        <p:spPr>
-          <a:xfrm>
-            <a:off x="733680" y="-215280"/>
-            <a:ext cx="8637480" cy="901080"/>
-          </a:xfrm>
-          <a:prstGeom prst="rect">
-            <a:avLst/>
-          </a:prstGeom>
-          <a:noFill/>
-          <a:ln w="0">
-            <a:noFill/>
-          </a:ln>
-        </p:spPr>
-        <p:txBody>
-          <a:bodyPr lIns="0" rIns="0" tIns="0" bIns="0" anchor="ctr">
-            <a:spAutoFit/>
-          </a:bodyPr>
-          <a:p>
-            <a:pPr indent="0" algn="ctr" defTabSz="914400">
-              <a:lnSpc>
-                <a:spcPct val="100000"/>
-              </a:lnSpc>
-              <a:buNone/>
-              <a:tabLst>
-                <a:tab algn="l" pos="0"/>
-              </a:tabLst>
-            </a:pPr>
-            <a:r>
-              <a:rPr b="1" lang="en-US" sz="2400" strike="noStrike" u="none">
-                <a:solidFill>
-                  <a:srgbClr val="000000"/>
-                </a:solidFill>
-                <a:effectLst/>
-                <a:uFillTx/>
-                <a:latin typeface="FreeSans"/>
-                <a:ea typeface="DejaVu Sans"/>
-              </a:rPr>
-              <a:t>cars collection</a:t>
-            </a:r>
-            <a:endParaRPr b="0" lang="en-US" sz="2400" strike="noStrike" u="none">
-              <a:solidFill>
-                <a:schemeClr val="dk1"/>
               </a:solidFill>
               <a:effectLst/>
               <a:uFillTx/>
@@ -7557,7 +6332,7 @@
       </p:sp>
       <p:graphicFrame>
         <p:nvGraphicFramePr>
-          <p:cNvPr id="85" name="Table 78"/>
+          <p:cNvPr id="82" name="Table 78"/>
           <p:cNvGraphicFramePr/>
           <p:nvPr/>
         </p:nvGraphicFramePr>
@@ -7595,7 +6370,7 @@
                           <a:latin typeface="FreeSans"/>
                           <a:ea typeface="DejaVu Sans"/>
                         </a:rPr>
-                        <a:t>carId</a:t>
+                        <a:t>id : string</a:t>
                       </a:r>
                       <a:endParaRPr b="0" lang="en-IN" sz="1800" strike="noStrike" u="none">
                         <a:solidFill>
@@ -7722,7 +6497,7 @@
                           <a:latin typeface="FreeSans"/>
                           <a:ea typeface="DejaVu Sans"/>
                         </a:rPr>
-                        <a:t>brand</a:t>
+                        <a:t>brand : string</a:t>
                       </a:r>
                       <a:endParaRPr b="0" lang="en-IN" sz="1800" strike="noStrike" u="none">
                         <a:solidFill>
@@ -7852,7 +6627,7 @@
                           <a:latin typeface="FreeSans"/>
                           <a:ea typeface="DejaVu Sans"/>
                         </a:rPr>
-                        <a:t>model</a:t>
+                        <a:t>model : string</a:t>
                       </a:r>
                       <a:endParaRPr b="0" lang="en-IN" sz="1800" strike="noStrike" u="none">
                         <a:solidFill>
@@ -7982,7 +6757,7 @@
                           <a:latin typeface="FreeSans"/>
                           <a:ea typeface="DejaVu Sans"/>
                         </a:rPr>
-                        <a:t>year</a:t>
+                        <a:t>year : number</a:t>
                       </a:r>
                       <a:endParaRPr b="0" lang="en-IN" sz="1800" strike="noStrike" u="none">
                         <a:solidFill>
@@ -8112,7 +6887,7 @@
                           <a:latin typeface="FreeSans"/>
                           <a:ea typeface="DejaVu Sans"/>
                         </a:rPr>
-                        <a:t>type</a:t>
+                        <a:t>type : string</a:t>
                       </a:r>
                       <a:endParaRPr b="0" lang="en-IN" sz="1800" strike="noStrike" u="none">
                         <a:solidFill>
@@ -8242,7 +7017,7 @@
                           <a:latin typeface="FreeSans"/>
                           <a:ea typeface="DejaVu Sans"/>
                         </a:rPr>
-                        <a:t>seats</a:t>
+                        <a:t>seats : number</a:t>
                       </a:r>
                       <a:endParaRPr b="0" lang="en-IN" sz="1800" strike="noStrike" u="none">
                         <a:solidFill>
@@ -8372,7 +7147,7 @@
                           <a:latin typeface="FreeSans"/>
                           <a:ea typeface="DejaVu Sans"/>
                         </a:rPr>
-                        <a:t>fuelType</a:t>
+                        <a:t>fuelType : string</a:t>
                       </a:r>
                       <a:endParaRPr b="0" lang="en-IN" sz="1800" strike="noStrike" u="none">
                         <a:solidFill>
@@ -8502,7 +7277,7 @@
                           <a:latin typeface="FreeSans"/>
                           <a:ea typeface="DejaVu Sans"/>
                         </a:rPr>
-                        <a:t>transmission</a:t>
+                        <a:t>transmission : string</a:t>
                       </a:r>
                       <a:endParaRPr b="0" lang="en-IN" sz="1800" strike="noStrike" u="none">
                         <a:solidFill>
@@ -8632,7 +7407,7 @@
                           <a:latin typeface="FreeSans"/>
                           <a:ea typeface="DejaVu Sans"/>
                         </a:rPr>
-                        <a:t>pricePerDay</a:t>
+                        <a:t>pricePerDay : number</a:t>
                       </a:r>
                       <a:endParaRPr b="0" lang="en-IN" sz="1800" strike="noStrike" u="none">
                         <a:solidFill>
@@ -8762,7 +7537,7 @@
                           <a:latin typeface="FreeSans"/>
                           <a:ea typeface="DejaVu Sans"/>
                         </a:rPr>
-                        <a:t>location</a:t>
+                        <a:t>location : string</a:t>
                       </a:r>
                       <a:endParaRPr b="0" lang="en-IN" sz="1800" strike="noStrike" u="none">
                         <a:solidFill>
@@ -8892,7 +7667,7 @@
                           <a:latin typeface="FreeSans"/>
                           <a:ea typeface="DejaVu Sans"/>
                         </a:rPr>
-                        <a:t>images</a:t>
+                        <a:t>images : string</a:t>
                       </a:r>
                       <a:endParaRPr b="0" lang="en-IN" sz="1800" strike="noStrike" u="none">
                         <a:solidFill>
@@ -9022,7 +7797,7 @@
                           <a:latin typeface="FreeSans"/>
                           <a:ea typeface="DejaVu Sans"/>
                         </a:rPr>
-                        <a:t>features</a:t>
+                        <a:t>features : string</a:t>
                       </a:r>
                       <a:endParaRPr b="0" lang="en-IN" sz="1800" strike="noStrike" u="none">
                         <a:solidFill>
@@ -9152,7 +7927,7 @@
                           <a:latin typeface="FreeSans"/>
                           <a:ea typeface="DejaVu Sans"/>
                         </a:rPr>
-                        <a:t>isAvailable</a:t>
+                        <a:t>isAvailable : boolean</a:t>
                       </a:r>
                       <a:endParaRPr b="0" lang="en-IN" sz="1800" strike="noStrike" u="none">
                         <a:solidFill>
@@ -9282,7 +8057,7 @@
                           <a:latin typeface="FreeSans"/>
                           <a:ea typeface="DejaVu Sans"/>
                         </a:rPr>
-                        <a:t>createdAt</a:t>
+                        <a:t>createdAt : timestamp</a:t>
                       </a:r>
                       <a:endParaRPr b="0" lang="en-IN" sz="1800" strike="noStrike" u="none">
                         <a:solidFill>
@@ -9405,8 +8180,8 @@
         <p:txBody>
           <a:bodyPr/>
           <a:p>
-            <a:fld id="{55C5C720-8877-434A-BB54-820DFE413DCF}" type="slidenum">
-              <a:t>15</a:t>
+            <a:fld id="{90050C00-72FC-447B-BF5C-547AC5FCDA5C}" type="slidenum">
+              <a:t>14</a:t>
             </a:fld>
           </a:p>
         </p:txBody>
@@ -9424,7 +8199,7 @@
 </p:sld>
 </file>
 
-<file path=ppt/slides/slide16.xml><?xml version="1.0" encoding="utf-8"?>
+<file path=ppt/slides/slide15.xml><?xml version="1.0" encoding="utf-8"?>
 <p:sld xmlns:a="http://schemas.openxmlformats.org/drawingml/2006/main" xmlns:p="http://schemas.openxmlformats.org/presentationml/2006/main" xmlns:r="http://schemas.openxmlformats.org/officeDocument/2006/relationships" xmlns:p14="http://schemas.microsoft.com/office/powerpoint/2010/main" xmlns:p15="http://schemas.microsoft.com/office/powerpoint/2012/main" xmlns:mc="http://schemas.openxmlformats.org/markup-compatibility/2006">
   <p:cSld>
     <p:spTree>
@@ -9443,7 +8218,7 @@
       </p:grpSpPr>
       <p:sp>
         <p:nvSpPr>
-          <p:cNvPr id="86" name="PlaceHolder 1"/>
+          <p:cNvPr id="83" name="PlaceHolder 1"/>
           <p:cNvSpPr>
             <a:spLocks noGrp="1"/>
           </p:cNvSpPr>
@@ -9453,8 +8228,8 @@
         </p:nvSpPr>
         <p:spPr>
           <a:xfrm>
-            <a:off x="734400" y="-720"/>
-            <a:ext cx="8637480" cy="901080"/>
+            <a:off x="734400" y="-1080"/>
+            <a:ext cx="8637120" cy="901440"/>
           </a:xfrm>
           <a:prstGeom prst="rect">
             <a:avLst/>
@@ -9490,9 +8265,9 @@
               </a:rPr>
               <a:t>bookings collection</a:t>
             </a:r>
-            <a:endParaRPr b="0" lang="en-US" sz="2400" strike="noStrike" u="none">
-              <a:solidFill>
-                <a:schemeClr val="dk1"/>
+            <a:endParaRPr b="0" lang="en-IN" sz="2400" strike="noStrike" u="none">
+              <a:solidFill>
+                <a:srgbClr val="000000"/>
               </a:solidFill>
               <a:effectLst/>
               <a:uFillTx/>
@@ -9503,7 +8278,7 @@
       </p:sp>
       <p:graphicFrame>
         <p:nvGraphicFramePr>
-          <p:cNvPr id="87" name="Table 80"/>
+          <p:cNvPr id="84" name="Table 80"/>
           <p:cNvGraphicFramePr/>
           <p:nvPr/>
         </p:nvGraphicFramePr>
@@ -9541,7 +8316,7 @@
                           <a:latin typeface="FreeSans"/>
                           <a:ea typeface="DejaVu Sans"/>
                         </a:rPr>
-                        <a:t>bookingId</a:t>
+                        <a:t>id : string</a:t>
                       </a:r>
                       <a:endParaRPr b="0" lang="en-IN" sz="1800" strike="noStrike" u="none">
                         <a:solidFill>
@@ -9668,7 +8443,7 @@
                           <a:latin typeface="FreeSans"/>
                           <a:ea typeface="DejaVu Sans"/>
                         </a:rPr>
-                        <a:t>userId</a:t>
+                        <a:t>userId : string</a:t>
                       </a:r>
                       <a:endParaRPr b="0" lang="en-IN" sz="1800" strike="noStrike" u="none">
                         <a:solidFill>
@@ -9798,7 +8573,7 @@
                           <a:latin typeface="FreeSans"/>
                           <a:ea typeface="DejaVu Sans"/>
                         </a:rPr>
-                        <a:t>carId</a:t>
+                        <a:t>carId : string</a:t>
                       </a:r>
                       <a:endParaRPr b="0" lang="en-IN" sz="1800" strike="noStrike" u="none">
                         <a:solidFill>
@@ -9928,7 +8703,7 @@
                           <a:latin typeface="FreeSans"/>
                           <a:ea typeface="DejaVu Sans"/>
                         </a:rPr>
-                        <a:t>startDate</a:t>
+                        <a:t>startDate : string</a:t>
                       </a:r>
                       <a:endParaRPr b="0" lang="en-IN" sz="1800" strike="noStrike" u="none">
                         <a:solidFill>
@@ -10058,7 +8833,7 @@
                           <a:latin typeface="FreeSans"/>
                           <a:ea typeface="DejaVu Sans"/>
                         </a:rPr>
-                        <a:t>endDate</a:t>
+                        <a:t>endDate : string</a:t>
                       </a:r>
                       <a:endParaRPr b="0" lang="en-IN" sz="1800" strike="noStrike" u="none">
                         <a:solidFill>
@@ -10188,7 +8963,7 @@
                           <a:latin typeface="FreeSans"/>
                           <a:ea typeface="DejaVu Sans"/>
                         </a:rPr>
-                        <a:t>totalDays</a:t>
+                        <a:t>totalDays : number</a:t>
                       </a:r>
                       <a:endParaRPr b="0" lang="en-IN" sz="1800" strike="noStrike" u="none">
                         <a:solidFill>
@@ -10318,7 +9093,7 @@
                           <a:latin typeface="FreeSans"/>
                           <a:ea typeface="DejaVu Sans"/>
                         </a:rPr>
-                        <a:t>pricePerDay</a:t>
+                        <a:t>pricePerDay : number</a:t>
                       </a:r>
                       <a:endParaRPr b="0" lang="en-IN" sz="1800" strike="noStrike" u="none">
                         <a:solidFill>
@@ -10448,7 +9223,7 @@
                           <a:latin typeface="FreeSans"/>
                           <a:ea typeface="DejaVu Sans"/>
                         </a:rPr>
-                        <a:t>totalPrice</a:t>
+                        <a:t>totalPrice : number</a:t>
                       </a:r>
                       <a:endParaRPr b="0" lang="en-IN" sz="1800" strike="noStrike" u="none">
                         <a:solidFill>
@@ -10578,7 +9353,7 @@
                           <a:latin typeface="FreeSans"/>
                           <a:ea typeface="DejaVu Sans"/>
                         </a:rPr>
-                        <a:t>status</a:t>
+                        <a:t>status : string</a:t>
                       </a:r>
                       <a:endParaRPr b="0" lang="en-IN" sz="1800" strike="noStrike" u="none">
                         <a:solidFill>
@@ -10708,7 +9483,7 @@
                           <a:latin typeface="FreeSans"/>
                           <a:ea typeface="DejaVu Sans"/>
                         </a:rPr>
-                        <a:t>pickupLocation</a:t>
+                        <a:t>pickupLocation : string</a:t>
                       </a:r>
                       <a:endParaRPr b="0" lang="en-IN" sz="1800" strike="noStrike" u="none">
                         <a:solidFill>
@@ -10838,7 +9613,7 @@
                           <a:latin typeface="FreeSans"/>
                           <a:ea typeface="DejaVu Sans"/>
                         </a:rPr>
-                        <a:t>createdAt</a:t>
+                        <a:t>createdAt : timestamp</a:t>
                       </a:r>
                       <a:endParaRPr b="0" lang="en-IN" sz="1800" strike="noStrike" u="none">
                         <a:solidFill>
@@ -10961,8 +9736,8 @@
         <p:txBody>
           <a:bodyPr/>
           <a:p>
-            <a:fld id="{A632F651-5BAB-49E8-97E9-23C2A0FA4D28}" type="slidenum">
-              <a:t>16</a:t>
+            <a:fld id="{51697B23-A5D4-4029-80C8-35ED76C18F08}" type="slidenum">
+              <a:t>15</a:t>
             </a:fld>
           </a:p>
         </p:txBody>
@@ -10980,7 +9755,7 @@
 </p:sld>
 </file>
 
-<file path=ppt/slides/slide17.xml><?xml version="1.0" encoding="utf-8"?>
+<file path=ppt/slides/slide16.xml><?xml version="1.0" encoding="utf-8"?>
 <p:sld xmlns:a="http://schemas.openxmlformats.org/drawingml/2006/main" xmlns:p="http://schemas.openxmlformats.org/presentationml/2006/main" xmlns:r="http://schemas.openxmlformats.org/officeDocument/2006/relationships" xmlns:p14="http://schemas.microsoft.com/office/powerpoint/2010/main" xmlns:p15="http://schemas.microsoft.com/office/powerpoint/2012/main" xmlns:mc="http://schemas.openxmlformats.org/markup-compatibility/2006">
   <p:cSld>
     <p:spTree>
@@ -10999,7 +9774,7 @@
       </p:grpSpPr>
       <p:sp>
         <p:nvSpPr>
-          <p:cNvPr id="88" name="PlaceHolder 1"/>
+          <p:cNvPr id="85" name="PlaceHolder 1"/>
           <p:cNvSpPr>
             <a:spLocks noGrp="1"/>
           </p:cNvSpPr>
@@ -11009,8 +9784,8 @@
         </p:nvSpPr>
         <p:spPr>
           <a:xfrm>
-            <a:off x="720000" y="358200"/>
-            <a:ext cx="8637480" cy="901080"/>
+            <a:off x="720000" y="357840"/>
+            <a:ext cx="8637120" cy="901440"/>
           </a:xfrm>
           <a:prstGeom prst="rect">
             <a:avLst/>
@@ -11046,9 +9821,9 @@
               </a:rPr>
               <a:t>reviews collection</a:t>
             </a:r>
-            <a:endParaRPr b="0" lang="en-US" sz="2400" strike="noStrike" u="none">
-              <a:solidFill>
-                <a:schemeClr val="dk1"/>
+            <a:endParaRPr b="0" lang="en-IN" sz="2400" strike="noStrike" u="none">
+              <a:solidFill>
+                <a:srgbClr val="000000"/>
               </a:solidFill>
               <a:effectLst/>
               <a:uFillTx/>
@@ -11059,7 +9834,7 @@
       </p:sp>
       <p:graphicFrame>
         <p:nvGraphicFramePr>
-          <p:cNvPr id="89" name="Table 82"/>
+          <p:cNvPr id="86" name="Table 82"/>
           <p:cNvGraphicFramePr/>
           <p:nvPr/>
         </p:nvGraphicFramePr>
@@ -11097,7 +9872,7 @@
                           <a:latin typeface="FreeSans"/>
                           <a:ea typeface="DejaVu Sans"/>
                         </a:rPr>
-                        <a:t>reviewId</a:t>
+                        <a:t>id : string</a:t>
                       </a:r>
                       <a:endParaRPr b="0" lang="en-IN" sz="1800" strike="noStrike" u="none">
                         <a:solidFill>
@@ -11224,7 +9999,7 @@
                           <a:latin typeface="FreeSans"/>
                           <a:ea typeface="DejaVu Sans"/>
                         </a:rPr>
-                        <a:t>bookingId</a:t>
+                        <a:t>bookingId : string</a:t>
                       </a:r>
                       <a:endParaRPr b="0" lang="en-IN" sz="1800" strike="noStrike" u="none">
                         <a:solidFill>
@@ -11354,7 +10129,7 @@
                           <a:latin typeface="FreeSans"/>
                           <a:ea typeface="DejaVu Sans"/>
                         </a:rPr>
-                        <a:t>carId</a:t>
+                        <a:t>carId : string</a:t>
                       </a:r>
                       <a:endParaRPr b="0" lang="en-IN" sz="1800" strike="noStrike" u="none">
                         <a:solidFill>
@@ -11484,7 +10259,7 @@
                           <a:latin typeface="FreeSans"/>
                           <a:ea typeface="DejaVu Sans"/>
                         </a:rPr>
-                        <a:t>userId</a:t>
+                        <a:t>userId : string</a:t>
                       </a:r>
                       <a:endParaRPr b="0" lang="en-IN" sz="1800" strike="noStrike" u="none">
                         <a:solidFill>
@@ -11614,7 +10389,7 @@
                           <a:latin typeface="FreeSans"/>
                           <a:ea typeface="DejaVu Sans"/>
                         </a:rPr>
-                        <a:t>rating</a:t>
+                        <a:t>rating : number</a:t>
                       </a:r>
                       <a:endParaRPr b="0" lang="en-IN" sz="1800" strike="noStrike" u="none">
                         <a:solidFill>
@@ -11744,7 +10519,7 @@
                           <a:latin typeface="FreeSans"/>
                           <a:ea typeface="DejaVu Sans"/>
                         </a:rPr>
-                        <a:t>comment</a:t>
+                        <a:t>comment : string</a:t>
                       </a:r>
                       <a:endParaRPr b="0" lang="en-IN" sz="1800" strike="noStrike" u="none">
                         <a:solidFill>
@@ -11874,7 +10649,7 @@
                           <a:latin typeface="FreeSans"/>
                           <a:ea typeface="DejaVu Sans"/>
                         </a:rPr>
-                        <a:t>createdAt</a:t>
+                        <a:t>createdAt : timestamp</a:t>
                       </a:r>
                       <a:endParaRPr b="0" lang="en-IN" sz="1800" strike="noStrike" u="none">
                         <a:solidFill>
@@ -11997,8 +10772,8 @@
         <p:txBody>
           <a:bodyPr/>
           <a:p>
-            <a:fld id="{BA3693C1-CF99-465D-A234-6347893C3E7B}" type="slidenum">
-              <a:t>17</a:t>
+            <a:fld id="{BAB87D9B-333D-4EF1-99D7-E1DFAAE28EE4}" type="slidenum">
+              <a:t>16</a:t>
             </a:fld>
           </a:p>
         </p:txBody>
@@ -12045,8 +10820,8 @@
         </p:nvSpPr>
         <p:spPr>
           <a:xfrm>
-            <a:off x="2334600" y="1144440"/>
-            <a:ext cx="5080320" cy="671400"/>
+            <a:off x="2334600" y="1144080"/>
+            <a:ext cx="5079960" cy="671760"/>
           </a:xfrm>
           <a:prstGeom prst="rect">
             <a:avLst/>
@@ -12082,9 +10857,9 @@
               </a:rPr>
               <a:t>Project Proposal &amp; Planning</a:t>
             </a:r>
-            <a:endParaRPr b="0" lang="en-US" sz="3200" strike="noStrike" u="none">
-              <a:solidFill>
-                <a:schemeClr val="dk1"/>
+            <a:endParaRPr b="0" lang="en-IN" sz="3200" strike="noStrike" u="none">
+              <a:solidFill>
+                <a:srgbClr val="000000"/>
               </a:solidFill>
               <a:effectLst/>
               <a:uFillTx/>
@@ -12106,7 +10881,7 @@
         <p:spPr>
           <a:xfrm>
             <a:off x="1371600" y="2514600"/>
-            <a:ext cx="7541280" cy="2409480"/>
+            <a:ext cx="7540920" cy="2409120"/>
           </a:xfrm>
           <a:prstGeom prst="rect">
             <a:avLst/>
@@ -12147,9 +10922,9 @@
               </a:rPr>
               <a:t>We aim to develop a car rental platform , that lets users rent cars for a specific time.</a:t>
             </a:r>
-            <a:endParaRPr b="0" lang="en-US" sz="2400" strike="noStrike" u="none">
-              <a:solidFill>
-                <a:schemeClr val="dk1"/>
+            <a:endParaRPr b="0" lang="en-IN" sz="2400" strike="noStrike" u="none">
+              <a:solidFill>
+                <a:srgbClr val="000000"/>
               </a:solidFill>
               <a:effectLst/>
               <a:uFillTx/>
@@ -12169,9 +10944,9 @@
                 <a:tab algn="l" pos="0"/>
               </a:tabLst>
             </a:pPr>
-            <a:endParaRPr b="0" lang="en-US" sz="2400" strike="noStrike" u="none">
-              <a:solidFill>
-                <a:schemeClr val="dk1"/>
+            <a:endParaRPr b="0" lang="en-IN" sz="2400" strike="noStrike" u="none">
+              <a:solidFill>
+                <a:srgbClr val="000000"/>
               </a:solidFill>
               <a:effectLst/>
               <a:uFillTx/>
@@ -12208,9 +10983,9 @@
               </a:rPr>
               <a:t>The system will provide administrative tools for managing vehicles , bookings and users.</a:t>
             </a:r>
-            <a:endParaRPr b="0" lang="en-US" sz="2400" strike="noStrike" u="none">
-              <a:solidFill>
-                <a:schemeClr val="dk1"/>
+            <a:endParaRPr b="0" lang="en-IN" sz="2400" strike="noStrike" u="none">
+              <a:solidFill>
+                <a:srgbClr val="000000"/>
               </a:solidFill>
               <a:effectLst/>
               <a:uFillTx/>
@@ -12233,7 +11008,7 @@
         <p:txBody>
           <a:bodyPr/>
           <a:p>
-            <a:fld id="{DEF10550-4E4B-4D62-82CE-F24A49C53028}" type="slidenum">
+            <a:fld id="{0AF8EBA7-8DD6-4C9A-A03B-B7ACEC7D1344}" type="slidenum">
               <a:t>2</a:t>
             </a:fld>
           </a:p>
@@ -12281,8 +11056,8 @@
         </p:nvSpPr>
         <p:spPr>
           <a:xfrm>
-            <a:off x="720000" y="473040"/>
-            <a:ext cx="8637480" cy="671400"/>
+            <a:off x="720000" y="472680"/>
+            <a:ext cx="8637120" cy="671760"/>
           </a:xfrm>
           <a:prstGeom prst="rect">
             <a:avLst/>
@@ -12318,9 +11093,9 @@
               </a:rPr>
               <a:t>Problem Statment</a:t>
             </a:r>
-            <a:endParaRPr b="0" lang="en-US" sz="3200" strike="noStrike" u="none">
-              <a:solidFill>
-                <a:schemeClr val="dk1"/>
+            <a:endParaRPr b="0" lang="en-IN" sz="3200" strike="noStrike" u="none">
+              <a:solidFill>
+                <a:srgbClr val="000000"/>
               </a:solidFill>
               <a:effectLst/>
               <a:uFillTx/>
@@ -12342,7 +11117,7 @@
         <p:spPr>
           <a:xfrm>
             <a:off x="720000" y="1440000"/>
-            <a:ext cx="8637480" cy="3597480"/>
+            <a:ext cx="8637120" cy="3597120"/>
           </a:xfrm>
           <a:prstGeom prst="rect">
             <a:avLst/>
@@ -12383,9 +11158,9 @@
               </a:rPr>
               <a:t>Traditional car rental systems often rely on manual or semi-digital processes that are inefficient, time-consuming, and prone to errors.</a:t>
             </a:r>
-            <a:endParaRPr b="0" lang="en-US" sz="2400" strike="noStrike" u="none">
-              <a:solidFill>
-                <a:schemeClr val="dk1"/>
+            <a:endParaRPr b="0" lang="en-IN" sz="2400" strike="noStrike" u="none">
+              <a:solidFill>
+                <a:srgbClr val="000000"/>
               </a:solidFill>
               <a:effectLst/>
               <a:uFillTx/>
@@ -12419,9 +11194,9 @@
               </a:rPr>
               <a:t>Customers lack access to real-time vehicle availability, while service providers face challenges in managing bookings and vehicle data.</a:t>
             </a:r>
-            <a:endParaRPr b="0" lang="en-US" sz="2400" strike="noStrike" u="none">
-              <a:solidFill>
-                <a:schemeClr val="dk1"/>
+            <a:endParaRPr b="0" lang="en-IN" sz="2400" strike="noStrike" u="none">
+              <a:solidFill>
+                <a:srgbClr val="000000"/>
               </a:solidFill>
               <a:effectLst/>
               <a:uFillTx/>
@@ -12455,9 +11230,9 @@
               </a:rPr>
               <a:t>This project proposes the development of a web-based car rental platform to streamline rental operations and improve user experience.</a:t>
             </a:r>
-            <a:endParaRPr b="0" lang="en-US" sz="2400" strike="noStrike" u="none">
-              <a:solidFill>
-                <a:schemeClr val="dk1"/>
+            <a:endParaRPr b="0" lang="en-IN" sz="2400" strike="noStrike" u="none">
+              <a:solidFill>
+                <a:srgbClr val="000000"/>
               </a:solidFill>
               <a:effectLst/>
               <a:uFillTx/>
@@ -12480,7 +11255,7 @@
         <p:txBody>
           <a:bodyPr/>
           <a:p>
-            <a:fld id="{9E2CE3CA-95A6-4CD5-95BB-952D0BC345C2}" type="slidenum">
+            <a:fld id="{0D825E9C-A213-4B7A-86FD-E08EB9CF9F69}" type="slidenum">
               <a:t>3</a:t>
             </a:fld>
           </a:p>
@@ -12528,8 +11303,8 @@
         </p:nvSpPr>
         <p:spPr>
           <a:xfrm>
-            <a:off x="720000" y="473040"/>
-            <a:ext cx="8637480" cy="671400"/>
+            <a:off x="720000" y="472680"/>
+            <a:ext cx="8637120" cy="671760"/>
           </a:xfrm>
           <a:prstGeom prst="rect">
             <a:avLst/>
@@ -12565,9 +11340,9 @@
               </a:rPr>
               <a:t>System Analysis (Existing System)</a:t>
             </a:r>
-            <a:endParaRPr b="0" lang="en-US" sz="3200" strike="noStrike" u="none">
-              <a:solidFill>
-                <a:schemeClr val="dk1"/>
+            <a:endParaRPr b="0" lang="en-IN" sz="3200" strike="noStrike" u="none">
+              <a:solidFill>
+                <a:srgbClr val="000000"/>
               </a:solidFill>
               <a:effectLst/>
               <a:uFillTx/>
@@ -12589,7 +11364,7 @@
         <p:spPr>
           <a:xfrm>
             <a:off x="720000" y="1440000"/>
-            <a:ext cx="8637480" cy="3597480"/>
+            <a:ext cx="8637120" cy="3597120"/>
           </a:xfrm>
           <a:prstGeom prst="rect">
             <a:avLst/>
@@ -12630,9 +11405,9 @@
               </a:rPr>
               <a:t>The existing car rental systems primarily rely on manual processes or basic digital tools such as phone calls , paper records , and spreadsheets.</a:t>
             </a:r>
-            <a:endParaRPr b="0" lang="en-US" sz="2400" strike="noStrike" u="none">
-              <a:solidFill>
-                <a:schemeClr val="dk1"/>
+            <a:endParaRPr b="0" lang="en-IN" sz="2400" strike="noStrike" u="none">
+              <a:solidFill>
+                <a:srgbClr val="000000"/>
               </a:solidFill>
               <a:effectLst/>
               <a:uFillTx/>
@@ -12666,9 +11441,9 @@
               </a:rPr>
               <a:t>Customers are required to contact the rental service provider directly to inquire about vehicle availability, pricing and booking details</a:t>
             </a:r>
-            <a:endParaRPr b="0" lang="en-US" sz="2400" strike="noStrike" u="none">
-              <a:solidFill>
-                <a:schemeClr val="dk1"/>
+            <a:endParaRPr b="0" lang="en-IN" sz="2400" strike="noStrike" u="none">
+              <a:solidFill>
+                <a:srgbClr val="000000"/>
               </a:solidFill>
               <a:effectLst/>
               <a:uFillTx/>
@@ -12702,9 +11477,9 @@
               </a:rPr>
               <a:t>Real examples of existing systems and how we are different:</a:t>
             </a:r>
-            <a:endParaRPr b="0" lang="en-US" sz="2400" strike="noStrike" u="none">
-              <a:solidFill>
-                <a:schemeClr val="dk1"/>
+            <a:endParaRPr b="0" lang="en-IN" sz="2400" strike="noStrike" u="none">
+              <a:solidFill>
+                <a:srgbClr val="000000"/>
               </a:solidFill>
               <a:effectLst/>
               <a:uFillTx/>
@@ -12738,9 +11513,9 @@
               </a:rPr>
               <a:t>Olacabs : does not allow self-drive</a:t>
             </a:r>
-            <a:endParaRPr b="0" lang="en-US" sz="2400" strike="noStrike" u="none">
-              <a:solidFill>
-                <a:schemeClr val="dk1"/>
+            <a:endParaRPr b="0" lang="en-IN" sz="2400" strike="noStrike" u="none">
+              <a:solidFill>
+                <a:srgbClr val="000000"/>
               </a:solidFill>
               <a:effectLst/>
               <a:uFillTx/>
@@ -12774,9 +11549,9 @@
               </a:rPr>
               <a:t>Zoomcar : does not allow web platform</a:t>
             </a:r>
-            <a:endParaRPr b="0" lang="en-US" sz="2400" strike="noStrike" u="none">
-              <a:solidFill>
-                <a:schemeClr val="dk1"/>
+            <a:endParaRPr b="0" lang="en-IN" sz="2400" strike="noStrike" u="none">
+              <a:solidFill>
+                <a:srgbClr val="000000"/>
               </a:solidFill>
               <a:effectLst/>
               <a:uFillTx/>
@@ -12799,7 +11574,7 @@
         <p:txBody>
           <a:bodyPr/>
           <a:p>
-            <a:fld id="{C3E366DF-AB6C-41F1-82B4-C68CE3B234C4}" type="slidenum">
+            <a:fld id="{938E0087-8131-4CFB-AE40-64DE87097ABF}" type="slidenum">
               <a:t>4</a:t>
             </a:fld>
           </a:p>
@@ -12847,8 +11622,8 @@
         </p:nvSpPr>
         <p:spPr>
           <a:xfrm>
-            <a:off x="720000" y="473040"/>
-            <a:ext cx="8637480" cy="671400"/>
+            <a:off x="720000" y="472680"/>
+            <a:ext cx="8637120" cy="671760"/>
           </a:xfrm>
           <a:prstGeom prst="rect">
             <a:avLst/>
@@ -12884,9 +11659,9 @@
               </a:rPr>
               <a:t>System Analysis (Proposed System)</a:t>
             </a:r>
-            <a:endParaRPr b="0" lang="en-US" sz="3200" strike="noStrike" u="none">
-              <a:solidFill>
-                <a:schemeClr val="dk1"/>
+            <a:endParaRPr b="0" lang="en-IN" sz="3200" strike="noStrike" u="none">
+              <a:solidFill>
+                <a:srgbClr val="000000"/>
               </a:solidFill>
               <a:effectLst/>
               <a:uFillTx/>
@@ -12908,7 +11683,7 @@
         <p:spPr>
           <a:xfrm>
             <a:off x="720000" y="1440000"/>
-            <a:ext cx="8637480" cy="3597480"/>
+            <a:ext cx="8637120" cy="3597120"/>
           </a:xfrm>
           <a:prstGeom prst="rect">
             <a:avLst/>
@@ -12949,9 +11724,9 @@
               </a:rPr>
               <a:t>The proposed system is a web-based car rental platform designed to overcome the limitations of the existing system by automating rental operationss and providing a centralized digital solution</a:t>
             </a:r>
-            <a:endParaRPr b="0" lang="en-US" sz="2400" strike="noStrike" u="none">
-              <a:solidFill>
-                <a:schemeClr val="dk1"/>
+            <a:endParaRPr b="0" lang="en-IN" sz="2400" strike="noStrike" u="none">
+              <a:solidFill>
+                <a:srgbClr val="000000"/>
               </a:solidFill>
               <a:effectLst/>
               <a:uFillTx/>
@@ -12985,9 +11760,9 @@
               </a:rPr>
               <a:t>The system allows customers to browse available vehicles, make booking online , and manage their reservations conveniently.</a:t>
             </a:r>
-            <a:endParaRPr b="0" lang="en-US" sz="2400" strike="noStrike" u="none">
-              <a:solidFill>
-                <a:schemeClr val="dk1"/>
+            <a:endParaRPr b="0" lang="en-IN" sz="2400" strike="noStrike" u="none">
+              <a:solidFill>
+                <a:srgbClr val="000000"/>
               </a:solidFill>
               <a:effectLst/>
               <a:uFillTx/>
@@ -13021,9 +11796,9 @@
               </a:rPr>
               <a:t>Administrators can manage vehicles , users, and bookings through a secure dashboard</a:t>
             </a:r>
-            <a:endParaRPr b="0" lang="en-US" sz="2400" strike="noStrike" u="none">
-              <a:solidFill>
-                <a:schemeClr val="dk1"/>
+            <a:endParaRPr b="0" lang="en-IN" sz="2400" strike="noStrike" u="none">
+              <a:solidFill>
+                <a:srgbClr val="000000"/>
               </a:solidFill>
               <a:effectLst/>
               <a:uFillTx/>
@@ -13046,7 +11821,7 @@
         <p:txBody>
           <a:bodyPr/>
           <a:p>
-            <a:fld id="{88F698D6-95EC-459C-B89E-EABA3FB18EFD}" type="slidenum">
+            <a:fld id="{6CCD7791-C0DF-4EB8-AB71-2CE94EA37C6B}" type="slidenum">
               <a:t>5</a:t>
             </a:fld>
           </a:p>
@@ -13095,7 +11870,7 @@
         <p:spPr>
           <a:xfrm>
             <a:off x="720000" y="360000"/>
-            <a:ext cx="8637480" cy="897480"/>
+            <a:ext cx="8637120" cy="897120"/>
           </a:xfrm>
           <a:prstGeom prst="rect">
             <a:avLst/>
@@ -13115,6 +11890,9 @@
                 <a:spcPct val="90000"/>
               </a:lnSpc>
               <a:buNone/>
+              <a:tabLst>
+                <a:tab algn="l" pos="0"/>
+              </a:tabLst>
             </a:pPr>
             <a:r>
               <a:rPr b="1" lang="en-US" sz="3200" strike="noStrike" u="none">
@@ -13128,9 +11906,9 @@
               </a:rPr>
               <a:t>Modules and submodules</a:t>
             </a:r>
-            <a:endParaRPr b="0" lang="en-US" sz="3200" strike="noStrike" u="none">
-              <a:solidFill>
-                <a:schemeClr val="dk1"/>
+            <a:endParaRPr b="0" lang="en-IN" sz="3200" strike="noStrike" u="none">
+              <a:solidFill>
+                <a:srgbClr val="000000"/>
               </a:solidFill>
               <a:effectLst/>
               <a:uFillTx/>
@@ -13148,7 +11926,7 @@
         <p:spPr>
           <a:xfrm>
             <a:off x="661680" y="1834200"/>
-            <a:ext cx="8637480" cy="3046680"/>
+            <a:ext cx="8637120" cy="3046320"/>
           </a:xfrm>
           <a:prstGeom prst="rect">
             <a:avLst/>
@@ -13546,7 +12324,7 @@
         <p:spPr>
           <a:xfrm>
             <a:off x="720000" y="360000"/>
-            <a:ext cx="8637480" cy="897480"/>
+            <a:ext cx="8637120" cy="897120"/>
           </a:xfrm>
           <a:prstGeom prst="rect">
             <a:avLst/>
@@ -13566,6 +12344,9 @@
                 <a:spcPct val="90000"/>
               </a:lnSpc>
               <a:buNone/>
+              <a:tabLst>
+                <a:tab algn="l" pos="0"/>
+              </a:tabLst>
             </a:pPr>
             <a:r>
               <a:rPr b="1" lang="en-US" sz="3200" strike="noStrike" u="none">
@@ -13579,9 +12360,9 @@
               </a:rPr>
               <a:t>Modules and submodules</a:t>
             </a:r>
-            <a:endParaRPr b="0" lang="en-US" sz="3200" strike="noStrike" u="none">
-              <a:solidFill>
-                <a:schemeClr val="dk1"/>
+            <a:endParaRPr b="0" lang="en-IN" sz="3200" strike="noStrike" u="none">
+              <a:solidFill>
+                <a:srgbClr val="000000"/>
               </a:solidFill>
               <a:effectLst/>
               <a:uFillTx/>
@@ -13603,7 +12384,7 @@
         <p:spPr>
           <a:xfrm>
             <a:off x="720000" y="1388880"/>
-            <a:ext cx="8637480" cy="3836160"/>
+            <a:ext cx="8637120" cy="3835800"/>
           </a:xfrm>
           <a:prstGeom prst="rect">
             <a:avLst/>
@@ -13643,9 +12424,9 @@
               </a:rPr>
               <a:t>Booking Module:</a:t>
             </a:r>
-            <a:endParaRPr b="0" lang="en-US" sz="1800" strike="noStrike" u="none">
-              <a:solidFill>
-                <a:schemeClr val="dk1"/>
+            <a:endParaRPr b="0" lang="en-IN" sz="1800" strike="noStrike" u="none">
+              <a:solidFill>
+                <a:srgbClr val="000000"/>
               </a:solidFill>
               <a:effectLst/>
               <a:uFillTx/>
@@ -13678,9 +12459,9 @@
               </a:rPr>
               <a:t>Search available cars</a:t>
             </a:r>
-            <a:endParaRPr b="0" lang="en-US" sz="1800" strike="noStrike" u="none">
-              <a:solidFill>
-                <a:schemeClr val="dk1"/>
+            <a:endParaRPr b="0" lang="en-IN" sz="1800" strike="noStrike" u="none">
+              <a:solidFill>
+                <a:srgbClr val="000000"/>
               </a:solidFill>
               <a:effectLst/>
               <a:uFillTx/>
@@ -13713,9 +12494,9 @@
               </a:rPr>
               <a:t>Select rental date and duration</a:t>
             </a:r>
-            <a:endParaRPr b="0" lang="en-US" sz="1800" strike="noStrike" u="none">
-              <a:solidFill>
-                <a:schemeClr val="dk1"/>
+            <a:endParaRPr b="0" lang="en-IN" sz="1800" strike="noStrike" u="none">
+              <a:solidFill>
+                <a:srgbClr val="000000"/>
               </a:solidFill>
               <a:effectLst/>
               <a:uFillTx/>
@@ -13748,9 +12529,9 @@
               </a:rPr>
               <a:t>Create new Booking</a:t>
             </a:r>
-            <a:endParaRPr b="0" lang="en-US" sz="1800" strike="noStrike" u="none">
-              <a:solidFill>
-                <a:schemeClr val="dk1"/>
+            <a:endParaRPr b="0" lang="en-IN" sz="1800" strike="noStrike" u="none">
+              <a:solidFill>
+                <a:srgbClr val="000000"/>
               </a:solidFill>
               <a:effectLst/>
               <a:uFillTx/>
@@ -13783,9 +12564,9 @@
               </a:rPr>
               <a:t>Modify booking details</a:t>
             </a:r>
-            <a:endParaRPr b="0" lang="en-US" sz="1800" strike="noStrike" u="none">
-              <a:solidFill>
-                <a:schemeClr val="dk1"/>
+            <a:endParaRPr b="0" lang="en-IN" sz="1800" strike="noStrike" u="none">
+              <a:solidFill>
+                <a:srgbClr val="000000"/>
               </a:solidFill>
               <a:effectLst/>
               <a:uFillTx/>
@@ -13818,9 +12599,9 @@
               </a:rPr>
               <a:t>Cancel booking</a:t>
             </a:r>
-            <a:endParaRPr b="0" lang="en-US" sz="1800" strike="noStrike" u="none">
-              <a:solidFill>
-                <a:schemeClr val="dk1"/>
+            <a:endParaRPr b="0" lang="en-IN" sz="1800" strike="noStrike" u="none">
+              <a:solidFill>
+                <a:srgbClr val="000000"/>
               </a:solidFill>
               <a:effectLst/>
               <a:uFillTx/>
@@ -13853,9 +12634,9 @@
               </a:rPr>
               <a:t>Booking confirmation and status update</a:t>
             </a:r>
-            <a:endParaRPr b="0" lang="en-US" sz="1800" strike="noStrike" u="none">
-              <a:solidFill>
-                <a:schemeClr val="dk1"/>
+            <a:endParaRPr b="0" lang="en-IN" sz="1800" strike="noStrike" u="none">
+              <a:solidFill>
+                <a:srgbClr val="000000"/>
               </a:solidFill>
               <a:effectLst/>
               <a:uFillTx/>
@@ -13871,10 +12652,13 @@
                 <a:spcPts val="1001"/>
               </a:spcBef>
               <a:buNone/>
-            </a:pPr>
-            <a:endParaRPr b="0" lang="en-US" sz="1800" strike="noStrike" u="none">
-              <a:solidFill>
-                <a:schemeClr val="dk1"/>
+              <a:tabLst>
+                <a:tab algn="l" pos="0"/>
+              </a:tabLst>
+            </a:pPr>
+            <a:endParaRPr b="0" lang="en-IN" sz="1800" strike="noStrike" u="none">
+              <a:solidFill>
+                <a:srgbClr val="000000"/>
               </a:solidFill>
               <a:effectLst/>
               <a:uFillTx/>
@@ -13894,6 +12678,9 @@
               </a:buClr>
               <a:buFont typeface="Arial"/>
               <a:buChar char="•"/>
+              <a:tabLst>
+                <a:tab algn="l" pos="0"/>
+              </a:tabLst>
             </a:pPr>
             <a:r>
               <a:rPr b="1" lang="en-US" sz="1800" strike="noStrike" u="none">
@@ -13907,9 +12694,9 @@
               </a:rPr>
               <a:t>Admin module:</a:t>
             </a:r>
-            <a:endParaRPr b="0" lang="en-US" sz="1800" strike="noStrike" u="none">
-              <a:solidFill>
-                <a:schemeClr val="dk1"/>
+            <a:endParaRPr b="0" lang="en-IN" sz="1800" strike="noStrike" u="none">
+              <a:solidFill>
+                <a:srgbClr val="000000"/>
               </a:solidFill>
               <a:effectLst/>
               <a:uFillTx/>
@@ -13929,6 +12716,9 @@
               </a:buClr>
               <a:buFont typeface="Arial"/>
               <a:buChar char="•"/>
+              <a:tabLst>
+                <a:tab algn="l" pos="0"/>
+              </a:tabLst>
             </a:pPr>
             <a:r>
               <a:rPr b="0" lang="en-US" sz="1800" strike="noStrike" u="none">
@@ -13942,9 +12732,9 @@
               </a:rPr>
               <a:t>Admin login</a:t>
             </a:r>
-            <a:endParaRPr b="0" lang="en-US" sz="1800" strike="noStrike" u="none">
-              <a:solidFill>
-                <a:schemeClr val="dk1"/>
+            <a:endParaRPr b="0" lang="en-IN" sz="1800" strike="noStrike" u="none">
+              <a:solidFill>
+                <a:srgbClr val="000000"/>
               </a:solidFill>
               <a:effectLst/>
               <a:uFillTx/>
@@ -13964,6 +12754,9 @@
               </a:buClr>
               <a:buFont typeface="Arial"/>
               <a:buChar char="•"/>
+              <a:tabLst>
+                <a:tab algn="l" pos="0"/>
+              </a:tabLst>
             </a:pPr>
             <a:r>
               <a:rPr b="0" lang="en-US" sz="1800" strike="noStrike" u="none">
@@ -13977,9 +12770,9 @@
               </a:rPr>
               <a:t>Manage users</a:t>
             </a:r>
-            <a:endParaRPr b="0" lang="en-US" sz="1800" strike="noStrike" u="none">
-              <a:solidFill>
-                <a:schemeClr val="dk1"/>
+            <a:endParaRPr b="0" lang="en-IN" sz="1800" strike="noStrike" u="none">
+              <a:solidFill>
+                <a:srgbClr val="000000"/>
               </a:solidFill>
               <a:effectLst/>
               <a:uFillTx/>
@@ -13999,6 +12792,9 @@
               </a:buClr>
               <a:buFont typeface="Arial"/>
               <a:buChar char="•"/>
+              <a:tabLst>
+                <a:tab algn="l" pos="0"/>
+              </a:tabLst>
             </a:pPr>
             <a:r>
               <a:rPr b="0" lang="en-US" sz="1800" strike="noStrike" u="none">
@@ -14012,9 +12808,9 @@
               </a:rPr>
               <a:t>Manage cars</a:t>
             </a:r>
-            <a:endParaRPr b="0" lang="en-US" sz="1800" strike="noStrike" u="none">
-              <a:solidFill>
-                <a:schemeClr val="dk1"/>
+            <a:endParaRPr b="0" lang="en-IN" sz="1800" strike="noStrike" u="none">
+              <a:solidFill>
+                <a:srgbClr val="000000"/>
               </a:solidFill>
               <a:effectLst/>
               <a:uFillTx/>
@@ -14034,6 +12830,9 @@
               </a:buClr>
               <a:buFont typeface="Arial"/>
               <a:buChar char="•"/>
+              <a:tabLst>
+                <a:tab algn="l" pos="0"/>
+              </a:tabLst>
             </a:pPr>
             <a:r>
               <a:rPr b="0" lang="en-US" sz="1800" strike="noStrike" u="none">
@@ -14047,9 +12846,9 @@
               </a:rPr>
               <a:t>Manage bookings</a:t>
             </a:r>
-            <a:endParaRPr b="0" lang="en-US" sz="1800" strike="noStrike" u="none">
-              <a:solidFill>
-                <a:schemeClr val="dk1"/>
+            <a:endParaRPr b="0" lang="en-IN" sz="1800" strike="noStrike" u="none">
+              <a:solidFill>
+                <a:srgbClr val="000000"/>
               </a:solidFill>
               <a:effectLst/>
               <a:uFillTx/>
@@ -14065,10 +12864,13 @@
                 <a:spcPts val="1001"/>
               </a:spcBef>
               <a:buNone/>
-            </a:pPr>
-            <a:endParaRPr b="0" lang="en-US" sz="1800" strike="noStrike" u="none">
-              <a:solidFill>
-                <a:schemeClr val="dk1"/>
+              <a:tabLst>
+                <a:tab algn="l" pos="0"/>
+              </a:tabLst>
+            </a:pPr>
+            <a:endParaRPr b="0" lang="en-IN" sz="1800" strike="noStrike" u="none">
+              <a:solidFill>
+                <a:srgbClr val="000000"/>
               </a:solidFill>
               <a:effectLst/>
               <a:uFillTx/>
@@ -14119,8 +12921,8 @@
         </p:nvSpPr>
         <p:spPr>
           <a:xfrm>
-            <a:off x="720000" y="357840"/>
-            <a:ext cx="8637480" cy="901800"/>
+            <a:off x="720000" y="357480"/>
+            <a:ext cx="8637120" cy="902160"/>
           </a:xfrm>
           <a:prstGeom prst="rect">
             <a:avLst/>
@@ -14156,9 +12958,9 @@
               </a:rPr>
               <a:t>Technical Specification</a:t>
             </a:r>
-            <a:endParaRPr b="0" lang="en-US" sz="3200" strike="noStrike" u="none">
-              <a:solidFill>
-                <a:schemeClr val="dk1"/>
+            <a:endParaRPr b="0" lang="en-IN" sz="3200" strike="noStrike" u="none">
+              <a:solidFill>
+                <a:srgbClr val="000000"/>
               </a:solidFill>
               <a:effectLst/>
               <a:uFillTx/>
@@ -14180,7 +12982,7 @@
         <p:spPr>
           <a:xfrm>
             <a:off x="720000" y="1440000"/>
-            <a:ext cx="8637480" cy="3597480"/>
+            <a:ext cx="8637120" cy="3597120"/>
           </a:xfrm>
           <a:prstGeom prst="rect">
             <a:avLst/>
@@ -14221,9 +13023,9 @@
               </a:rPr>
               <a:t>Frontend:</a:t>
             </a:r>
-            <a:endParaRPr b="0" lang="en-US" sz="2400" strike="noStrike" u="none">
-              <a:solidFill>
-                <a:schemeClr val="dk1"/>
+            <a:endParaRPr b="0" lang="en-IN" sz="2400" strike="noStrike" u="none">
+              <a:solidFill>
+                <a:srgbClr val="000000"/>
               </a:solidFill>
               <a:effectLst/>
               <a:uFillTx/>
@@ -14257,9 +13059,9 @@
               </a:rPr>
               <a:t>HTML,CSS,JS</a:t>
             </a:r>
-            <a:endParaRPr b="0" lang="en-US" sz="2400" strike="noStrike" u="none">
-              <a:solidFill>
-                <a:schemeClr val="dk1"/>
+            <a:endParaRPr b="0" lang="en-IN" sz="2400" strike="noStrike" u="none">
+              <a:solidFill>
+                <a:srgbClr val="000000"/>
               </a:solidFill>
               <a:effectLst/>
               <a:uFillTx/>
@@ -14293,9 +13095,9 @@
               </a:rPr>
               <a:t>ReactJS</a:t>
             </a:r>
-            <a:endParaRPr b="0" lang="en-US" sz="2400" strike="noStrike" u="none">
-              <a:solidFill>
-                <a:schemeClr val="dk1"/>
+            <a:endParaRPr b="0" lang="en-IN" sz="2400" strike="noStrike" u="none">
+              <a:solidFill>
+                <a:srgbClr val="000000"/>
               </a:solidFill>
               <a:effectLst/>
               <a:uFillTx/>
@@ -14329,9 +13131,9 @@
               </a:rPr>
               <a:t>Backend:</a:t>
             </a:r>
-            <a:endParaRPr b="0" lang="en-US" sz="2400" strike="noStrike" u="none">
-              <a:solidFill>
-                <a:schemeClr val="dk1"/>
+            <a:endParaRPr b="0" lang="en-IN" sz="2400" strike="noStrike" u="none">
+              <a:solidFill>
+                <a:srgbClr val="000000"/>
               </a:solidFill>
               <a:effectLst/>
               <a:uFillTx/>
@@ -14365,9 +13167,9 @@
               </a:rPr>
               <a:t>NodeJS</a:t>
             </a:r>
-            <a:endParaRPr b="0" lang="en-US" sz="2400" strike="noStrike" u="none">
-              <a:solidFill>
-                <a:schemeClr val="dk1"/>
+            <a:endParaRPr b="0" lang="en-IN" sz="2400" strike="noStrike" u="none">
+              <a:solidFill>
+                <a:srgbClr val="000000"/>
               </a:solidFill>
               <a:effectLst/>
               <a:uFillTx/>
@@ -14401,9 +13203,9 @@
               </a:rPr>
               <a:t>Firebase</a:t>
             </a:r>
-            <a:endParaRPr b="0" lang="en-US" sz="2400" strike="noStrike" u="none">
-              <a:solidFill>
-                <a:schemeClr val="dk1"/>
+            <a:endParaRPr b="0" lang="en-IN" sz="2400" strike="noStrike" u="none">
+              <a:solidFill>
+                <a:srgbClr val="000000"/>
               </a:solidFill>
               <a:effectLst/>
               <a:uFillTx/>
@@ -14426,7 +13228,7 @@
         <p:txBody>
           <a:bodyPr/>
           <a:p>
-            <a:fld id="{71CA7259-C50E-4EF8-B7E6-ACBB5CAE8B68}" type="slidenum">
+            <a:fld id="{859C9172-CB62-4606-A786-88DA2B7930CA}" type="slidenum">
               <a:t>8</a:t>
             </a:fld>
           </a:p>
@@ -14474,8 +13276,8 @@
         </p:nvSpPr>
         <p:spPr>
           <a:xfrm>
-            <a:off x="685800" y="-216000"/>
-            <a:ext cx="8637480" cy="901800"/>
+            <a:off x="685800" y="-216360"/>
+            <a:ext cx="8637120" cy="902160"/>
           </a:xfrm>
           <a:prstGeom prst="rect">
             <a:avLst/>
@@ -14511,9 +13313,9 @@
               </a:rPr>
               <a:t>System Design</a:t>
             </a:r>
-            <a:endParaRPr b="0" lang="en-US" sz="3200" strike="noStrike" u="none">
-              <a:solidFill>
-                <a:schemeClr val="dk1"/>
+            <a:endParaRPr b="0" lang="en-IN" sz="3200" strike="noStrike" u="none">
+              <a:solidFill>
+                <a:srgbClr val="000000"/>
               </a:solidFill>
               <a:effectLst/>
               <a:uFillTx/>
@@ -14536,7 +13338,7 @@
         <p:spPr>
           <a:xfrm>
             <a:off x="1143360" y="666720"/>
-            <a:ext cx="7542000" cy="4818240"/>
+            <a:ext cx="7541640" cy="4817880"/>
           </a:xfrm>
           <a:prstGeom prst="rect">
             <a:avLst/>
@@ -14561,7 +13363,7 @@
         <p:txBody>
           <a:bodyPr/>
           <a:p>
-            <a:fld id="{42189E7C-C969-43ED-B004-1B9313D6AC67}" type="slidenum">
+            <a:fld id="{6DC49D55-8EA5-4716-A486-19929A72B7AF}" type="slidenum">
               <a:t>9</a:t>
             </a:fld>
           </a:p>

</xml_diff>